<commit_message>
docs(pitch): llenar columna A de la lámina 4 con el costo real de #240
Caso B: #241 no está en develop. La columna A del panel A/B/C lleva el
costo estimado del motor del ensayo de #240 (escenario sintético
demo-base, commit 6adcf53, USD 19,94); B, C y la recomendación quedan
«en integración». generar_v2.py ahora también renderiza los PNG.
Se ajustan los planos 3 y 4 del video, el bloque de demo del guion y
los SHA-256 del manifiesto. P-02 y P-03 de la matriz no cambian.

Refs #200

Co-Authored-By: Claude Opus 5.5 <noreply@anthropic.com>
</commit_message>
<xml_diff>
--- a/docs/specs/006-validacion-pitch-entrega/materiales/pitch-v2.pptx
+++ b/docs/specs/006-validacion-pitch-entrega/materiales/pitch-v2.pptx
@@ -5569,7 +5569,7 @@
               </a:defRPr>
             </a:pPr>
             <a:r>
-              <a:t>Diseño del panel de comparación A / B / C</a:t>
+              <a:t>Panel A / B / C: la columna A ya la calcula el motor</a:t>
             </a:r>
           </a:p>
         </p:txBody>
@@ -5653,7 +5653,7 @@
               </a:defRPr>
             </a:pPr>
             <a:r>
-              <a:t>Fuente: propuesta del evento y matriz P-02/P-03/P-05. Celdas sin dato: no atribuir cifras al motor.</a:t>
+              <a:t>Fuente: #240, PR #254 (6adcf53), 240-desglose-demo.json · demo-base: Bodega Quito → Hospital Norte → regreso, 210 kg, 20 bultos, 1 ayudante · combustible sintético USD 3,785/gal · matriz P-01; P-02 en curso.</a:t>
             </a:r>
           </a:p>
         </p:txBody>
@@ -5666,8 +5666,2192 @@
         </p:nvSpPr>
         <p:spPr>
           <a:xfrm>
-            <a:off x="694944" y="1444752"/>
+            <a:off x="694944" y="1389888"/>
             <a:ext cx="10808208" cy="502920"/>
+          </a:xfrm>
+          <a:prstGeom prst="roundRect">
+            <a:avLst/>
+          </a:prstGeom>
+          <a:solidFill>
+            <a:srgbClr val="E8F7FA"/>
+          </a:solidFill>
+          <a:ln w="12700">
+            <a:solidFill>
+              <a:srgbClr val="00A7C4"/>
+            </a:solidFill>
+          </a:ln>
+        </p:spPr>
+        <p:style>
+          <a:lnRef idx="1">
+            <a:schemeClr val="accent1"/>
+          </a:lnRef>
+          <a:fillRef idx="3">
+            <a:schemeClr val="accent1"/>
+          </a:fillRef>
+          <a:effectRef idx="2">
+            <a:schemeClr val="accent1"/>
+          </a:effectRef>
+          <a:fontRef idx="minor">
+            <a:schemeClr val="lt1"/>
+          </a:fontRef>
+        </p:style>
+        <p:txBody>
+          <a:bodyPr rtlCol="0" anchor="ctr"/>
+          <a:lstStyle/>
+          <a:p>
+            <a:pPr algn="ctr"/>
+          </a:p>
+        </p:txBody>
+      </p:sp>
+      <p:sp>
+        <p:nvSpPr>
+          <p:cNvPr id="8" name="TextBox 7"/>
+          <p:cNvSpPr txBox="1"/>
+          <p:nvPr/>
+        </p:nvSpPr>
+        <p:spPr>
+          <a:xfrm>
+            <a:off x="877824" y="1481328"/>
+            <a:ext cx="10424160" cy="310896"/>
+          </a:xfrm>
+          <a:prstGeom prst="rect">
+            <a:avLst/>
+          </a:prstGeom>
+          <a:noFill/>
+        </p:spPr>
+        <p:txBody>
+          <a:bodyPr wrap="square" anchor="ctr" lIns="18288" rIns="18288" tIns="18288" bIns="18288">
+            <a:spAutoFit/>
+          </a:bodyPr>
+          <a:lstStyle/>
+          <a:p>
+            <a:pPr algn="ctr">
+              <a:spcAft>
+                <a:spcPts val="500"/>
+              </a:spcAft>
+              <a:defRPr sz="1700" b="1">
+                <a:solidFill>
+                  <a:srgbClr val="2D3748"/>
+                </a:solidFill>
+                <a:latin typeface="Liberation Sans"/>
+              </a:defRPr>
+            </a:pPr>
+            <a:r>
+              <a:t>A: costo estimado del motor · escenario sintético demo-base · commit 6adcf53</a:t>
+            </a:r>
+          </a:p>
+        </p:txBody>
+      </p:sp>
+      <p:sp>
+        <p:nvSpPr>
+          <p:cNvPr id="9" name="Rectangle 8"/>
+          <p:cNvSpPr/>
+          <p:nvPr/>
+        </p:nvSpPr>
+        <p:spPr>
+          <a:xfrm>
+            <a:off x="749808" y="2011680"/>
+            <a:ext cx="2615184" cy="566928"/>
+          </a:xfrm>
+          <a:prstGeom prst="rect">
+            <a:avLst/>
+          </a:prstGeom>
+          <a:solidFill>
+            <a:srgbClr val="00A7C4"/>
+          </a:solidFill>
+          <a:ln w="12700">
+            <a:solidFill>
+              <a:srgbClr val="00A7C4"/>
+            </a:solidFill>
+          </a:ln>
+        </p:spPr>
+        <p:style>
+          <a:lnRef idx="1">
+            <a:schemeClr val="accent1"/>
+          </a:lnRef>
+          <a:fillRef idx="3">
+            <a:schemeClr val="accent1"/>
+          </a:fillRef>
+          <a:effectRef idx="2">
+            <a:schemeClr val="accent1"/>
+          </a:effectRef>
+          <a:fontRef idx="minor">
+            <a:schemeClr val="lt1"/>
+          </a:fontRef>
+        </p:style>
+        <p:txBody>
+          <a:bodyPr rtlCol="0" anchor="ctr"/>
+          <a:lstStyle/>
+          <a:p>
+            <a:pPr algn="ctr"/>
+          </a:p>
+        </p:txBody>
+      </p:sp>
+      <p:sp>
+        <p:nvSpPr>
+          <p:cNvPr id="10" name="TextBox 9"/>
+          <p:cNvSpPr txBox="1"/>
+          <p:nvPr/>
+        </p:nvSpPr>
+        <p:spPr>
+          <a:xfrm>
+            <a:off x="813815" y="2103120"/>
+            <a:ext cx="2487168" cy="384048"/>
+          </a:xfrm>
+          <a:prstGeom prst="rect">
+            <a:avLst/>
+          </a:prstGeom>
+          <a:noFill/>
+        </p:spPr>
+        <p:txBody>
+          <a:bodyPr wrap="square" anchor="ctr" lIns="18288" rIns="18288" tIns="18288" bIns="18288">
+            <a:spAutoFit/>
+          </a:bodyPr>
+          <a:lstStyle/>
+          <a:p>
+            <a:pPr algn="ctr">
+              <a:spcAft>
+                <a:spcPts val="500"/>
+              </a:spcAft>
+              <a:defRPr sz="1600" b="1">
+                <a:solidFill>
+                  <a:srgbClr val="FFFFFF"/>
+                </a:solidFill>
+                <a:latin typeface="Liberation Sans"/>
+              </a:defRPr>
+            </a:pPr>
+            <a:r>
+              <a:t>Componente</a:t>
+            </a:r>
+          </a:p>
+        </p:txBody>
+      </p:sp>
+      <p:sp>
+        <p:nvSpPr>
+          <p:cNvPr id="11" name="Rectangle 10"/>
+          <p:cNvSpPr/>
+          <p:nvPr/>
+        </p:nvSpPr>
+        <p:spPr>
+          <a:xfrm>
+            <a:off x="3364991" y="2011680"/>
+            <a:ext cx="2962656" cy="566928"/>
+          </a:xfrm>
+          <a:prstGeom prst="rect">
+            <a:avLst/>
+          </a:prstGeom>
+          <a:solidFill>
+            <a:srgbClr val="00A7C4"/>
+          </a:solidFill>
+          <a:ln w="12700">
+            <a:solidFill>
+              <a:srgbClr val="00A7C4"/>
+            </a:solidFill>
+          </a:ln>
+        </p:spPr>
+        <p:style>
+          <a:lnRef idx="1">
+            <a:schemeClr val="accent1"/>
+          </a:lnRef>
+          <a:fillRef idx="3">
+            <a:schemeClr val="accent1"/>
+          </a:fillRef>
+          <a:effectRef idx="2">
+            <a:schemeClr val="accent1"/>
+          </a:effectRef>
+          <a:fontRef idx="minor">
+            <a:schemeClr val="lt1"/>
+          </a:fontRef>
+        </p:style>
+        <p:txBody>
+          <a:bodyPr rtlCol="0" anchor="ctr"/>
+          <a:lstStyle/>
+          <a:p>
+            <a:pPr algn="ctr"/>
+          </a:p>
+        </p:txBody>
+      </p:sp>
+      <p:sp>
+        <p:nvSpPr>
+          <p:cNvPr id="12" name="TextBox 11"/>
+          <p:cNvSpPr txBox="1"/>
+          <p:nvPr/>
+        </p:nvSpPr>
+        <p:spPr>
+          <a:xfrm>
+            <a:off x="3428999" y="2103120"/>
+            <a:ext cx="2834640" cy="384048"/>
+          </a:xfrm>
+          <a:prstGeom prst="rect">
+            <a:avLst/>
+          </a:prstGeom>
+          <a:noFill/>
+        </p:spPr>
+        <p:txBody>
+          <a:bodyPr wrap="square" anchor="ctr" lIns="18288" rIns="18288" tIns="18288" bIns="18288">
+            <a:spAutoFit/>
+          </a:bodyPr>
+          <a:lstStyle/>
+          <a:p>
+            <a:pPr algn="ctr">
+              <a:spcAft>
+                <a:spcPts val="500"/>
+              </a:spcAft>
+              <a:defRPr sz="1600" b="1">
+                <a:solidFill>
+                  <a:srgbClr val="FFFFFF"/>
+                </a:solidFill>
+                <a:latin typeface="Liberation Sans"/>
+              </a:defRPr>
+            </a:pPr>
+            <a:r>
+              <a:t>A · Flota propia</a:t>
+            </a:r>
+          </a:p>
+        </p:txBody>
+      </p:sp>
+      <p:sp>
+        <p:nvSpPr>
+          <p:cNvPr id="13" name="Rectangle 12"/>
+          <p:cNvSpPr/>
+          <p:nvPr/>
+        </p:nvSpPr>
+        <p:spPr>
+          <a:xfrm>
+            <a:off x="6327648" y="2011680"/>
+            <a:ext cx="2615184" cy="566928"/>
+          </a:xfrm>
+          <a:prstGeom prst="rect">
+            <a:avLst/>
+          </a:prstGeom>
+          <a:solidFill>
+            <a:srgbClr val="2D3748"/>
+          </a:solidFill>
+          <a:ln w="12700">
+            <a:solidFill>
+              <a:srgbClr val="2D3748"/>
+            </a:solidFill>
+          </a:ln>
+        </p:spPr>
+        <p:style>
+          <a:lnRef idx="1">
+            <a:schemeClr val="accent1"/>
+          </a:lnRef>
+          <a:fillRef idx="3">
+            <a:schemeClr val="accent1"/>
+          </a:fillRef>
+          <a:effectRef idx="2">
+            <a:schemeClr val="accent1"/>
+          </a:effectRef>
+          <a:fontRef idx="minor">
+            <a:schemeClr val="lt1"/>
+          </a:fontRef>
+        </p:style>
+        <p:txBody>
+          <a:bodyPr rtlCol="0" anchor="ctr"/>
+          <a:lstStyle/>
+          <a:p>
+            <a:pPr algn="ctr"/>
+          </a:p>
+        </p:txBody>
+      </p:sp>
+      <p:sp>
+        <p:nvSpPr>
+          <p:cNvPr id="14" name="TextBox 13"/>
+          <p:cNvSpPr txBox="1"/>
+          <p:nvPr/>
+        </p:nvSpPr>
+        <p:spPr>
+          <a:xfrm>
+            <a:off x="6391656" y="2103120"/>
+            <a:ext cx="2487168" cy="384048"/>
+          </a:xfrm>
+          <a:prstGeom prst="rect">
+            <a:avLst/>
+          </a:prstGeom>
+          <a:noFill/>
+        </p:spPr>
+        <p:txBody>
+          <a:bodyPr wrap="square" anchor="ctr" lIns="18288" rIns="18288" tIns="18288" bIns="18288">
+            <a:spAutoFit/>
+          </a:bodyPr>
+          <a:lstStyle/>
+          <a:p>
+            <a:pPr algn="ctr">
+              <a:spcAft>
+                <a:spcPts val="500"/>
+              </a:spcAft>
+              <a:defRPr sz="1600" b="1">
+                <a:solidFill>
+                  <a:srgbClr val="FFFFFF"/>
+                </a:solidFill>
+                <a:latin typeface="Liberation Sans"/>
+              </a:defRPr>
+            </a:pPr>
+            <a:r>
+              <a:t>B · Propia, críticos primero</a:t>
+            </a:r>
+          </a:p>
+        </p:txBody>
+      </p:sp>
+      <p:sp>
+        <p:nvSpPr>
+          <p:cNvPr id="15" name="Rectangle 14"/>
+          <p:cNvSpPr/>
+          <p:nvPr/>
+        </p:nvSpPr>
+        <p:spPr>
+          <a:xfrm>
+            <a:off x="8942832" y="2011680"/>
+            <a:ext cx="2615184" cy="566928"/>
+          </a:xfrm>
+          <a:prstGeom prst="rect">
+            <a:avLst/>
+          </a:prstGeom>
+          <a:solidFill>
+            <a:srgbClr val="2D3748"/>
+          </a:solidFill>
+          <a:ln w="12700">
+            <a:solidFill>
+              <a:srgbClr val="2D3748"/>
+            </a:solidFill>
+          </a:ln>
+        </p:spPr>
+        <p:style>
+          <a:lnRef idx="1">
+            <a:schemeClr val="accent1"/>
+          </a:lnRef>
+          <a:fillRef idx="3">
+            <a:schemeClr val="accent1"/>
+          </a:fillRef>
+          <a:effectRef idx="2">
+            <a:schemeClr val="accent1"/>
+          </a:effectRef>
+          <a:fontRef idx="minor">
+            <a:schemeClr val="lt1"/>
+          </a:fontRef>
+        </p:style>
+        <p:txBody>
+          <a:bodyPr rtlCol="0" anchor="ctr"/>
+          <a:lstStyle/>
+          <a:p>
+            <a:pPr algn="ctr"/>
+          </a:p>
+        </p:txBody>
+      </p:sp>
+      <p:sp>
+        <p:nvSpPr>
+          <p:cNvPr id="16" name="TextBox 15"/>
+          <p:cNvSpPr txBox="1"/>
+          <p:nvPr/>
+        </p:nvSpPr>
+        <p:spPr>
+          <a:xfrm>
+            <a:off x="9006840" y="2103120"/>
+            <a:ext cx="2487168" cy="384048"/>
+          </a:xfrm>
+          <a:prstGeom prst="rect">
+            <a:avLst/>
+          </a:prstGeom>
+          <a:noFill/>
+        </p:spPr>
+        <p:txBody>
+          <a:bodyPr wrap="square" anchor="ctr" lIns="18288" rIns="18288" tIns="18288" bIns="18288">
+            <a:spAutoFit/>
+          </a:bodyPr>
+          <a:lstStyle/>
+          <a:p>
+            <a:pPr algn="ctr">
+              <a:spcAft>
+                <a:spcPts val="500"/>
+              </a:spcAft>
+              <a:defRPr sz="1600" b="1">
+                <a:solidFill>
+                  <a:srgbClr val="FFFFFF"/>
+                </a:solidFill>
+                <a:latin typeface="Liberation Sans"/>
+              </a:defRPr>
+            </a:pPr>
+            <a:r>
+              <a:t>C · Contratada</a:t>
+            </a:r>
+          </a:p>
+        </p:txBody>
+      </p:sp>
+      <p:sp>
+        <p:nvSpPr>
+          <p:cNvPr id="17" name="Rectangle 16"/>
+          <p:cNvSpPr/>
+          <p:nvPr/>
+        </p:nvSpPr>
+        <p:spPr>
+          <a:xfrm>
+            <a:off x="749808" y="2578608"/>
+            <a:ext cx="2615184" cy="429768"/>
+          </a:xfrm>
+          <a:prstGeom prst="rect">
+            <a:avLst/>
+          </a:prstGeom>
+          <a:solidFill>
+            <a:srgbClr val="FFFFFF"/>
+          </a:solidFill>
+          <a:ln w="7620">
+            <a:solidFill>
+              <a:srgbClr val="D8E2E7"/>
+            </a:solidFill>
+          </a:ln>
+        </p:spPr>
+        <p:style>
+          <a:lnRef idx="1">
+            <a:schemeClr val="accent1"/>
+          </a:lnRef>
+          <a:fillRef idx="3">
+            <a:schemeClr val="accent1"/>
+          </a:fillRef>
+          <a:effectRef idx="2">
+            <a:schemeClr val="accent1"/>
+          </a:effectRef>
+          <a:fontRef idx="minor">
+            <a:schemeClr val="lt1"/>
+          </a:fontRef>
+        </p:style>
+        <p:txBody>
+          <a:bodyPr rtlCol="0" anchor="ctr"/>
+          <a:lstStyle/>
+          <a:p>
+            <a:pPr algn="ctr"/>
+          </a:p>
+        </p:txBody>
+      </p:sp>
+      <p:sp>
+        <p:nvSpPr>
+          <p:cNvPr id="18" name="TextBox 17"/>
+          <p:cNvSpPr txBox="1"/>
+          <p:nvPr/>
+        </p:nvSpPr>
+        <p:spPr>
+          <a:xfrm>
+            <a:off x="813815" y="2651760"/>
+            <a:ext cx="2487168" cy="283464"/>
+          </a:xfrm>
+          <a:prstGeom prst="rect">
+            <a:avLst/>
+          </a:prstGeom>
+          <a:noFill/>
+        </p:spPr>
+        <p:txBody>
+          <a:bodyPr wrap="square" anchor="ctr" lIns="18288" rIns="18288" tIns="18288" bIns="18288">
+            <a:spAutoFit/>
+          </a:bodyPr>
+          <a:lstStyle/>
+          <a:p>
+            <a:pPr algn="ctr">
+              <a:spcAft>
+                <a:spcPts val="500"/>
+              </a:spcAft>
+              <a:defRPr sz="1700" b="1">
+                <a:solidFill>
+                  <a:srgbClr val="2D3748"/>
+                </a:solidFill>
+                <a:latin typeface="Liberation Sans"/>
+              </a:defRPr>
+            </a:pPr>
+            <a:r>
+              <a:t>Combustible</a:t>
+            </a:r>
+          </a:p>
+        </p:txBody>
+      </p:sp>
+      <p:sp>
+        <p:nvSpPr>
+          <p:cNvPr id="19" name="Rectangle 18"/>
+          <p:cNvSpPr/>
+          <p:nvPr/>
+        </p:nvSpPr>
+        <p:spPr>
+          <a:xfrm>
+            <a:off x="3364991" y="2578608"/>
+            <a:ext cx="2962656" cy="429768"/>
+          </a:xfrm>
+          <a:prstGeom prst="rect">
+            <a:avLst/>
+          </a:prstGeom>
+          <a:solidFill>
+            <a:srgbClr val="FFFFFF"/>
+          </a:solidFill>
+          <a:ln w="7620">
+            <a:solidFill>
+              <a:srgbClr val="D8E2E7"/>
+            </a:solidFill>
+          </a:ln>
+        </p:spPr>
+        <p:style>
+          <a:lnRef idx="1">
+            <a:schemeClr val="accent1"/>
+          </a:lnRef>
+          <a:fillRef idx="3">
+            <a:schemeClr val="accent1"/>
+          </a:fillRef>
+          <a:effectRef idx="2">
+            <a:schemeClr val="accent1"/>
+          </a:effectRef>
+          <a:fontRef idx="minor">
+            <a:schemeClr val="lt1"/>
+          </a:fontRef>
+        </p:style>
+        <p:txBody>
+          <a:bodyPr rtlCol="0" anchor="ctr"/>
+          <a:lstStyle/>
+          <a:p>
+            <a:pPr algn="ctr"/>
+          </a:p>
+        </p:txBody>
+      </p:sp>
+      <p:sp>
+        <p:nvSpPr>
+          <p:cNvPr id="20" name="TextBox 19"/>
+          <p:cNvSpPr txBox="1"/>
+          <p:nvPr/>
+        </p:nvSpPr>
+        <p:spPr>
+          <a:xfrm>
+            <a:off x="3428999" y="2651760"/>
+            <a:ext cx="2834640" cy="283464"/>
+          </a:xfrm>
+          <a:prstGeom prst="rect">
+            <a:avLst/>
+          </a:prstGeom>
+          <a:noFill/>
+        </p:spPr>
+        <p:txBody>
+          <a:bodyPr wrap="square" anchor="ctr" lIns="18288" rIns="18288" tIns="18288" bIns="18288">
+            <a:spAutoFit/>
+          </a:bodyPr>
+          <a:lstStyle/>
+          <a:p>
+            <a:pPr algn="ctr">
+              <a:spcAft>
+                <a:spcPts val="500"/>
+              </a:spcAft>
+              <a:defRPr sz="1800" b="1">
+                <a:solidFill>
+                  <a:srgbClr val="2D3748"/>
+                </a:solidFill>
+                <a:latin typeface="Liberation Sans"/>
+              </a:defRPr>
+            </a:pPr>
+            <a:r>
+              <a:t>USD 2,26</a:t>
+            </a:r>
+          </a:p>
+        </p:txBody>
+      </p:sp>
+      <p:sp>
+        <p:nvSpPr>
+          <p:cNvPr id="21" name="Rectangle 20"/>
+          <p:cNvSpPr/>
+          <p:nvPr/>
+        </p:nvSpPr>
+        <p:spPr>
+          <a:xfrm>
+            <a:off x="6327648" y="2578608"/>
+            <a:ext cx="2615184" cy="429768"/>
+          </a:xfrm>
+          <a:prstGeom prst="rect">
+            <a:avLst/>
+          </a:prstGeom>
+          <a:solidFill>
+            <a:srgbClr val="FFFFFF"/>
+          </a:solidFill>
+          <a:ln w="7620">
+            <a:solidFill>
+              <a:srgbClr val="D8E2E7"/>
+            </a:solidFill>
+          </a:ln>
+        </p:spPr>
+        <p:style>
+          <a:lnRef idx="1">
+            <a:schemeClr val="accent1"/>
+          </a:lnRef>
+          <a:fillRef idx="3">
+            <a:schemeClr val="accent1"/>
+          </a:fillRef>
+          <a:effectRef idx="2">
+            <a:schemeClr val="accent1"/>
+          </a:effectRef>
+          <a:fontRef idx="minor">
+            <a:schemeClr val="lt1"/>
+          </a:fontRef>
+        </p:style>
+        <p:txBody>
+          <a:bodyPr rtlCol="0" anchor="ctr"/>
+          <a:lstStyle/>
+          <a:p>
+            <a:pPr algn="ctr"/>
+          </a:p>
+        </p:txBody>
+      </p:sp>
+      <p:sp>
+        <p:nvSpPr>
+          <p:cNvPr id="22" name="TextBox 21"/>
+          <p:cNvSpPr txBox="1"/>
+          <p:nvPr/>
+        </p:nvSpPr>
+        <p:spPr>
+          <a:xfrm>
+            <a:off x="6391656" y="2651760"/>
+            <a:ext cx="2487168" cy="283464"/>
+          </a:xfrm>
+          <a:prstGeom prst="rect">
+            <a:avLst/>
+          </a:prstGeom>
+          <a:noFill/>
+        </p:spPr>
+        <p:txBody>
+          <a:bodyPr wrap="square" anchor="ctr" lIns="18288" rIns="18288" tIns="18288" bIns="18288">
+            <a:spAutoFit/>
+          </a:bodyPr>
+          <a:lstStyle/>
+          <a:p>
+            <a:pPr algn="ctr">
+              <a:spcAft>
+                <a:spcPts val="500"/>
+              </a:spcAft>
+              <a:defRPr sz="1500" b="0">
+                <a:solidFill>
+                  <a:srgbClr val="556373"/>
+                </a:solidFill>
+                <a:latin typeface="Liberation Sans"/>
+              </a:defRPr>
+            </a:pPr>
+            <a:r>
+              <a:t>en integración</a:t>
+            </a:r>
+          </a:p>
+        </p:txBody>
+      </p:sp>
+      <p:sp>
+        <p:nvSpPr>
+          <p:cNvPr id="23" name="Rectangle 22"/>
+          <p:cNvSpPr/>
+          <p:nvPr/>
+        </p:nvSpPr>
+        <p:spPr>
+          <a:xfrm>
+            <a:off x="8942832" y="2578608"/>
+            <a:ext cx="2615184" cy="429768"/>
+          </a:xfrm>
+          <a:prstGeom prst="rect">
+            <a:avLst/>
+          </a:prstGeom>
+          <a:solidFill>
+            <a:srgbClr val="FFFFFF"/>
+          </a:solidFill>
+          <a:ln w="7620">
+            <a:solidFill>
+              <a:srgbClr val="D8E2E7"/>
+            </a:solidFill>
+          </a:ln>
+        </p:spPr>
+        <p:style>
+          <a:lnRef idx="1">
+            <a:schemeClr val="accent1"/>
+          </a:lnRef>
+          <a:fillRef idx="3">
+            <a:schemeClr val="accent1"/>
+          </a:fillRef>
+          <a:effectRef idx="2">
+            <a:schemeClr val="accent1"/>
+          </a:effectRef>
+          <a:fontRef idx="minor">
+            <a:schemeClr val="lt1"/>
+          </a:fontRef>
+        </p:style>
+        <p:txBody>
+          <a:bodyPr rtlCol="0" anchor="ctr"/>
+          <a:lstStyle/>
+          <a:p>
+            <a:pPr algn="ctr"/>
+          </a:p>
+        </p:txBody>
+      </p:sp>
+      <p:sp>
+        <p:nvSpPr>
+          <p:cNvPr id="24" name="TextBox 23"/>
+          <p:cNvSpPr txBox="1"/>
+          <p:nvPr/>
+        </p:nvSpPr>
+        <p:spPr>
+          <a:xfrm>
+            <a:off x="9006840" y="2651760"/>
+            <a:ext cx="2487168" cy="283464"/>
+          </a:xfrm>
+          <a:prstGeom prst="rect">
+            <a:avLst/>
+          </a:prstGeom>
+          <a:noFill/>
+        </p:spPr>
+        <p:txBody>
+          <a:bodyPr wrap="square" anchor="ctr" lIns="18288" rIns="18288" tIns="18288" bIns="18288">
+            <a:spAutoFit/>
+          </a:bodyPr>
+          <a:lstStyle/>
+          <a:p>
+            <a:pPr algn="ctr">
+              <a:spcAft>
+                <a:spcPts val="500"/>
+              </a:spcAft>
+              <a:defRPr sz="1500" b="0">
+                <a:solidFill>
+                  <a:srgbClr val="556373"/>
+                </a:solidFill>
+                <a:latin typeface="Liberation Sans"/>
+              </a:defRPr>
+            </a:pPr>
+            <a:r>
+              <a:t>en integración</a:t>
+            </a:r>
+          </a:p>
+        </p:txBody>
+      </p:sp>
+      <p:sp>
+        <p:nvSpPr>
+          <p:cNvPr id="25" name="Rectangle 24"/>
+          <p:cNvSpPr/>
+          <p:nvPr/>
+        </p:nvSpPr>
+        <p:spPr>
+          <a:xfrm>
+            <a:off x="749808" y="3008376"/>
+            <a:ext cx="2615184" cy="429768"/>
+          </a:xfrm>
+          <a:prstGeom prst="rect">
+            <a:avLst/>
+          </a:prstGeom>
+          <a:solidFill>
+            <a:srgbClr val="E8F7FA"/>
+          </a:solidFill>
+          <a:ln w="7620">
+            <a:solidFill>
+              <a:srgbClr val="D8E2E7"/>
+            </a:solidFill>
+          </a:ln>
+        </p:spPr>
+        <p:style>
+          <a:lnRef idx="1">
+            <a:schemeClr val="accent1"/>
+          </a:lnRef>
+          <a:fillRef idx="3">
+            <a:schemeClr val="accent1"/>
+          </a:fillRef>
+          <a:effectRef idx="2">
+            <a:schemeClr val="accent1"/>
+          </a:effectRef>
+          <a:fontRef idx="minor">
+            <a:schemeClr val="lt1"/>
+          </a:fontRef>
+        </p:style>
+        <p:txBody>
+          <a:bodyPr rtlCol="0" anchor="ctr"/>
+          <a:lstStyle/>
+          <a:p>
+            <a:pPr algn="ctr"/>
+          </a:p>
+        </p:txBody>
+      </p:sp>
+      <p:sp>
+        <p:nvSpPr>
+          <p:cNvPr id="26" name="TextBox 25"/>
+          <p:cNvSpPr txBox="1"/>
+          <p:nvPr/>
+        </p:nvSpPr>
+        <p:spPr>
+          <a:xfrm>
+            <a:off x="813815" y="3081528"/>
+            <a:ext cx="2487168" cy="283464"/>
+          </a:xfrm>
+          <a:prstGeom prst="rect">
+            <a:avLst/>
+          </a:prstGeom>
+          <a:noFill/>
+        </p:spPr>
+        <p:txBody>
+          <a:bodyPr wrap="square" anchor="ctr" lIns="18288" rIns="18288" tIns="18288" bIns="18288">
+            <a:spAutoFit/>
+          </a:bodyPr>
+          <a:lstStyle/>
+          <a:p>
+            <a:pPr algn="ctr">
+              <a:spcAft>
+                <a:spcPts val="500"/>
+              </a:spcAft>
+              <a:defRPr sz="1700" b="1">
+                <a:solidFill>
+                  <a:srgbClr val="2D3748"/>
+                </a:solidFill>
+                <a:latin typeface="Liberation Sans"/>
+              </a:defRPr>
+            </a:pPr>
+            <a:r>
+              <a:t>Desgaste</a:t>
+            </a:r>
+          </a:p>
+        </p:txBody>
+      </p:sp>
+      <p:sp>
+        <p:nvSpPr>
+          <p:cNvPr id="27" name="Rectangle 26"/>
+          <p:cNvSpPr/>
+          <p:nvPr/>
+        </p:nvSpPr>
+        <p:spPr>
+          <a:xfrm>
+            <a:off x="3364991" y="3008376"/>
+            <a:ext cx="2962656" cy="429768"/>
+          </a:xfrm>
+          <a:prstGeom prst="rect">
+            <a:avLst/>
+          </a:prstGeom>
+          <a:solidFill>
+            <a:srgbClr val="E8F7FA"/>
+          </a:solidFill>
+          <a:ln w="7620">
+            <a:solidFill>
+              <a:srgbClr val="D8E2E7"/>
+            </a:solidFill>
+          </a:ln>
+        </p:spPr>
+        <p:style>
+          <a:lnRef idx="1">
+            <a:schemeClr val="accent1"/>
+          </a:lnRef>
+          <a:fillRef idx="3">
+            <a:schemeClr val="accent1"/>
+          </a:fillRef>
+          <a:effectRef idx="2">
+            <a:schemeClr val="accent1"/>
+          </a:effectRef>
+          <a:fontRef idx="minor">
+            <a:schemeClr val="lt1"/>
+          </a:fontRef>
+        </p:style>
+        <p:txBody>
+          <a:bodyPr rtlCol="0" anchor="ctr"/>
+          <a:lstStyle/>
+          <a:p>
+            <a:pPr algn="ctr"/>
+          </a:p>
+        </p:txBody>
+      </p:sp>
+      <p:sp>
+        <p:nvSpPr>
+          <p:cNvPr id="28" name="TextBox 27"/>
+          <p:cNvSpPr txBox="1"/>
+          <p:nvPr/>
+        </p:nvSpPr>
+        <p:spPr>
+          <a:xfrm>
+            <a:off x="3428999" y="3081528"/>
+            <a:ext cx="2834640" cy="283464"/>
+          </a:xfrm>
+          <a:prstGeom prst="rect">
+            <a:avLst/>
+          </a:prstGeom>
+          <a:noFill/>
+        </p:spPr>
+        <p:txBody>
+          <a:bodyPr wrap="square" anchor="ctr" lIns="18288" rIns="18288" tIns="18288" bIns="18288">
+            <a:spAutoFit/>
+          </a:bodyPr>
+          <a:lstStyle/>
+          <a:p>
+            <a:pPr algn="ctr">
+              <a:spcAft>
+                <a:spcPts val="500"/>
+              </a:spcAft>
+              <a:defRPr sz="1800" b="1">
+                <a:solidFill>
+                  <a:srgbClr val="2D3748"/>
+                </a:solidFill>
+                <a:latin typeface="Liberation Sans"/>
+              </a:defRPr>
+            </a:pPr>
+            <a:r>
+              <a:t>USD 2,15</a:t>
+            </a:r>
+          </a:p>
+        </p:txBody>
+      </p:sp>
+      <p:sp>
+        <p:nvSpPr>
+          <p:cNvPr id="29" name="Rectangle 28"/>
+          <p:cNvSpPr/>
+          <p:nvPr/>
+        </p:nvSpPr>
+        <p:spPr>
+          <a:xfrm>
+            <a:off x="6327648" y="3008376"/>
+            <a:ext cx="2615184" cy="429768"/>
+          </a:xfrm>
+          <a:prstGeom prst="rect">
+            <a:avLst/>
+          </a:prstGeom>
+          <a:solidFill>
+            <a:srgbClr val="E8F7FA"/>
+          </a:solidFill>
+          <a:ln w="7620">
+            <a:solidFill>
+              <a:srgbClr val="D8E2E7"/>
+            </a:solidFill>
+          </a:ln>
+        </p:spPr>
+        <p:style>
+          <a:lnRef idx="1">
+            <a:schemeClr val="accent1"/>
+          </a:lnRef>
+          <a:fillRef idx="3">
+            <a:schemeClr val="accent1"/>
+          </a:fillRef>
+          <a:effectRef idx="2">
+            <a:schemeClr val="accent1"/>
+          </a:effectRef>
+          <a:fontRef idx="minor">
+            <a:schemeClr val="lt1"/>
+          </a:fontRef>
+        </p:style>
+        <p:txBody>
+          <a:bodyPr rtlCol="0" anchor="ctr"/>
+          <a:lstStyle/>
+          <a:p>
+            <a:pPr algn="ctr"/>
+          </a:p>
+        </p:txBody>
+      </p:sp>
+      <p:sp>
+        <p:nvSpPr>
+          <p:cNvPr id="30" name="TextBox 29"/>
+          <p:cNvSpPr txBox="1"/>
+          <p:nvPr/>
+        </p:nvSpPr>
+        <p:spPr>
+          <a:xfrm>
+            <a:off x="6391656" y="3081528"/>
+            <a:ext cx="2487168" cy="283464"/>
+          </a:xfrm>
+          <a:prstGeom prst="rect">
+            <a:avLst/>
+          </a:prstGeom>
+          <a:noFill/>
+        </p:spPr>
+        <p:txBody>
+          <a:bodyPr wrap="square" anchor="ctr" lIns="18288" rIns="18288" tIns="18288" bIns="18288">
+            <a:spAutoFit/>
+          </a:bodyPr>
+          <a:lstStyle/>
+          <a:p>
+            <a:pPr algn="ctr">
+              <a:spcAft>
+                <a:spcPts val="500"/>
+              </a:spcAft>
+              <a:defRPr sz="1500" b="0">
+                <a:solidFill>
+                  <a:srgbClr val="556373"/>
+                </a:solidFill>
+                <a:latin typeface="Liberation Sans"/>
+              </a:defRPr>
+            </a:pPr>
+            <a:r>
+              <a:t>en integración</a:t>
+            </a:r>
+          </a:p>
+        </p:txBody>
+      </p:sp>
+      <p:sp>
+        <p:nvSpPr>
+          <p:cNvPr id="31" name="Rectangle 30"/>
+          <p:cNvSpPr/>
+          <p:nvPr/>
+        </p:nvSpPr>
+        <p:spPr>
+          <a:xfrm>
+            <a:off x="8942832" y="3008376"/>
+            <a:ext cx="2615184" cy="429768"/>
+          </a:xfrm>
+          <a:prstGeom prst="rect">
+            <a:avLst/>
+          </a:prstGeom>
+          <a:solidFill>
+            <a:srgbClr val="E8F7FA"/>
+          </a:solidFill>
+          <a:ln w="7620">
+            <a:solidFill>
+              <a:srgbClr val="D8E2E7"/>
+            </a:solidFill>
+          </a:ln>
+        </p:spPr>
+        <p:style>
+          <a:lnRef idx="1">
+            <a:schemeClr val="accent1"/>
+          </a:lnRef>
+          <a:fillRef idx="3">
+            <a:schemeClr val="accent1"/>
+          </a:fillRef>
+          <a:effectRef idx="2">
+            <a:schemeClr val="accent1"/>
+          </a:effectRef>
+          <a:fontRef idx="minor">
+            <a:schemeClr val="lt1"/>
+          </a:fontRef>
+        </p:style>
+        <p:txBody>
+          <a:bodyPr rtlCol="0" anchor="ctr"/>
+          <a:lstStyle/>
+          <a:p>
+            <a:pPr algn="ctr"/>
+          </a:p>
+        </p:txBody>
+      </p:sp>
+      <p:sp>
+        <p:nvSpPr>
+          <p:cNvPr id="32" name="TextBox 31"/>
+          <p:cNvSpPr txBox="1"/>
+          <p:nvPr/>
+        </p:nvSpPr>
+        <p:spPr>
+          <a:xfrm>
+            <a:off x="9006840" y="3081528"/>
+            <a:ext cx="2487168" cy="283464"/>
+          </a:xfrm>
+          <a:prstGeom prst="rect">
+            <a:avLst/>
+          </a:prstGeom>
+          <a:noFill/>
+        </p:spPr>
+        <p:txBody>
+          <a:bodyPr wrap="square" anchor="ctr" lIns="18288" rIns="18288" tIns="18288" bIns="18288">
+            <a:spAutoFit/>
+          </a:bodyPr>
+          <a:lstStyle/>
+          <a:p>
+            <a:pPr algn="ctr">
+              <a:spcAft>
+                <a:spcPts val="500"/>
+              </a:spcAft>
+              <a:defRPr sz="1500" b="0">
+                <a:solidFill>
+                  <a:srgbClr val="556373"/>
+                </a:solidFill>
+                <a:latin typeface="Liberation Sans"/>
+              </a:defRPr>
+            </a:pPr>
+            <a:r>
+              <a:t>en integración</a:t>
+            </a:r>
+          </a:p>
+        </p:txBody>
+      </p:sp>
+      <p:sp>
+        <p:nvSpPr>
+          <p:cNvPr id="33" name="Rectangle 32"/>
+          <p:cNvSpPr/>
+          <p:nvPr/>
+        </p:nvSpPr>
+        <p:spPr>
+          <a:xfrm>
+            <a:off x="749808" y="3438144"/>
+            <a:ext cx="2615184" cy="429768"/>
+          </a:xfrm>
+          <a:prstGeom prst="rect">
+            <a:avLst/>
+          </a:prstGeom>
+          <a:solidFill>
+            <a:srgbClr val="FFFFFF"/>
+          </a:solidFill>
+          <a:ln w="7620">
+            <a:solidFill>
+              <a:srgbClr val="D8E2E7"/>
+            </a:solidFill>
+          </a:ln>
+        </p:spPr>
+        <p:style>
+          <a:lnRef idx="1">
+            <a:schemeClr val="accent1"/>
+          </a:lnRef>
+          <a:fillRef idx="3">
+            <a:schemeClr val="accent1"/>
+          </a:fillRef>
+          <a:effectRef idx="2">
+            <a:schemeClr val="accent1"/>
+          </a:effectRef>
+          <a:fontRef idx="minor">
+            <a:schemeClr val="lt1"/>
+          </a:fontRef>
+        </p:style>
+        <p:txBody>
+          <a:bodyPr rtlCol="0" anchor="ctr"/>
+          <a:lstStyle/>
+          <a:p>
+            <a:pPr algn="ctr"/>
+          </a:p>
+        </p:txBody>
+      </p:sp>
+      <p:sp>
+        <p:nvSpPr>
+          <p:cNvPr id="34" name="TextBox 33"/>
+          <p:cNvSpPr txBox="1"/>
+          <p:nvPr/>
+        </p:nvSpPr>
+        <p:spPr>
+          <a:xfrm>
+            <a:off x="813815" y="3511296"/>
+            <a:ext cx="2487168" cy="283464"/>
+          </a:xfrm>
+          <a:prstGeom prst="rect">
+            <a:avLst/>
+          </a:prstGeom>
+          <a:noFill/>
+        </p:spPr>
+        <p:txBody>
+          <a:bodyPr wrap="square" anchor="ctr" lIns="18288" rIns="18288" tIns="18288" bIns="18288">
+            <a:spAutoFit/>
+          </a:bodyPr>
+          <a:lstStyle/>
+          <a:p>
+            <a:pPr algn="ctr">
+              <a:spcAft>
+                <a:spcPts val="500"/>
+              </a:spcAft>
+              <a:defRPr sz="1700" b="1">
+                <a:solidFill>
+                  <a:srgbClr val="2D3748"/>
+                </a:solidFill>
+                <a:latin typeface="Liberation Sans"/>
+              </a:defRPr>
+            </a:pPr>
+            <a:r>
+              <a:t>Conductor y ayudantes</a:t>
+            </a:r>
+          </a:p>
+        </p:txBody>
+      </p:sp>
+      <p:sp>
+        <p:nvSpPr>
+          <p:cNvPr id="35" name="Rectangle 34"/>
+          <p:cNvSpPr/>
+          <p:nvPr/>
+        </p:nvSpPr>
+        <p:spPr>
+          <a:xfrm>
+            <a:off x="3364991" y="3438144"/>
+            <a:ext cx="2962656" cy="429768"/>
+          </a:xfrm>
+          <a:prstGeom prst="rect">
+            <a:avLst/>
+          </a:prstGeom>
+          <a:solidFill>
+            <a:srgbClr val="FFFFFF"/>
+          </a:solidFill>
+          <a:ln w="7620">
+            <a:solidFill>
+              <a:srgbClr val="D8E2E7"/>
+            </a:solidFill>
+          </a:ln>
+        </p:spPr>
+        <p:style>
+          <a:lnRef idx="1">
+            <a:schemeClr val="accent1"/>
+          </a:lnRef>
+          <a:fillRef idx="3">
+            <a:schemeClr val="accent1"/>
+          </a:fillRef>
+          <a:effectRef idx="2">
+            <a:schemeClr val="accent1"/>
+          </a:effectRef>
+          <a:fontRef idx="minor">
+            <a:schemeClr val="lt1"/>
+          </a:fontRef>
+        </p:style>
+        <p:txBody>
+          <a:bodyPr rtlCol="0" anchor="ctr"/>
+          <a:lstStyle/>
+          <a:p>
+            <a:pPr algn="ctr"/>
+          </a:p>
+        </p:txBody>
+      </p:sp>
+      <p:sp>
+        <p:nvSpPr>
+          <p:cNvPr id="36" name="TextBox 35"/>
+          <p:cNvSpPr txBox="1"/>
+          <p:nvPr/>
+        </p:nvSpPr>
+        <p:spPr>
+          <a:xfrm>
+            <a:off x="3428999" y="3511296"/>
+            <a:ext cx="2834640" cy="283464"/>
+          </a:xfrm>
+          <a:prstGeom prst="rect">
+            <a:avLst/>
+          </a:prstGeom>
+          <a:noFill/>
+        </p:spPr>
+        <p:txBody>
+          <a:bodyPr wrap="square" anchor="ctr" lIns="18288" rIns="18288" tIns="18288" bIns="18288">
+            <a:spAutoFit/>
+          </a:bodyPr>
+          <a:lstStyle/>
+          <a:p>
+            <a:pPr algn="ctr">
+              <a:spcAft>
+                <a:spcPts val="500"/>
+              </a:spcAft>
+              <a:defRPr sz="1800" b="1">
+                <a:solidFill>
+                  <a:srgbClr val="2D3748"/>
+                </a:solidFill>
+                <a:latin typeface="Liberation Sans"/>
+              </a:defRPr>
+            </a:pPr>
+            <a:r>
+              <a:t>USD 7,22 + 4,81</a:t>
+            </a:r>
+          </a:p>
+        </p:txBody>
+      </p:sp>
+      <p:sp>
+        <p:nvSpPr>
+          <p:cNvPr id="37" name="Rectangle 36"/>
+          <p:cNvSpPr/>
+          <p:nvPr/>
+        </p:nvSpPr>
+        <p:spPr>
+          <a:xfrm>
+            <a:off x="6327648" y="3438144"/>
+            <a:ext cx="2615184" cy="429768"/>
+          </a:xfrm>
+          <a:prstGeom prst="rect">
+            <a:avLst/>
+          </a:prstGeom>
+          <a:solidFill>
+            <a:srgbClr val="FFFFFF"/>
+          </a:solidFill>
+          <a:ln w="7620">
+            <a:solidFill>
+              <a:srgbClr val="D8E2E7"/>
+            </a:solidFill>
+          </a:ln>
+        </p:spPr>
+        <p:style>
+          <a:lnRef idx="1">
+            <a:schemeClr val="accent1"/>
+          </a:lnRef>
+          <a:fillRef idx="3">
+            <a:schemeClr val="accent1"/>
+          </a:fillRef>
+          <a:effectRef idx="2">
+            <a:schemeClr val="accent1"/>
+          </a:effectRef>
+          <a:fontRef idx="minor">
+            <a:schemeClr val="lt1"/>
+          </a:fontRef>
+        </p:style>
+        <p:txBody>
+          <a:bodyPr rtlCol="0" anchor="ctr"/>
+          <a:lstStyle/>
+          <a:p>
+            <a:pPr algn="ctr"/>
+          </a:p>
+        </p:txBody>
+      </p:sp>
+      <p:sp>
+        <p:nvSpPr>
+          <p:cNvPr id="38" name="TextBox 37"/>
+          <p:cNvSpPr txBox="1"/>
+          <p:nvPr/>
+        </p:nvSpPr>
+        <p:spPr>
+          <a:xfrm>
+            <a:off x="6391656" y="3511296"/>
+            <a:ext cx="2487168" cy="283464"/>
+          </a:xfrm>
+          <a:prstGeom prst="rect">
+            <a:avLst/>
+          </a:prstGeom>
+          <a:noFill/>
+        </p:spPr>
+        <p:txBody>
+          <a:bodyPr wrap="square" anchor="ctr" lIns="18288" rIns="18288" tIns="18288" bIns="18288">
+            <a:spAutoFit/>
+          </a:bodyPr>
+          <a:lstStyle/>
+          <a:p>
+            <a:pPr algn="ctr">
+              <a:spcAft>
+                <a:spcPts val="500"/>
+              </a:spcAft>
+              <a:defRPr sz="1500" b="0">
+                <a:solidFill>
+                  <a:srgbClr val="556373"/>
+                </a:solidFill>
+                <a:latin typeface="Liberation Sans"/>
+              </a:defRPr>
+            </a:pPr>
+            <a:r>
+              <a:t>en integración</a:t>
+            </a:r>
+          </a:p>
+        </p:txBody>
+      </p:sp>
+      <p:sp>
+        <p:nvSpPr>
+          <p:cNvPr id="39" name="Rectangle 38"/>
+          <p:cNvSpPr/>
+          <p:nvPr/>
+        </p:nvSpPr>
+        <p:spPr>
+          <a:xfrm>
+            <a:off x="8942832" y="3438144"/>
+            <a:ext cx="2615184" cy="429768"/>
+          </a:xfrm>
+          <a:prstGeom prst="rect">
+            <a:avLst/>
+          </a:prstGeom>
+          <a:solidFill>
+            <a:srgbClr val="FFFFFF"/>
+          </a:solidFill>
+          <a:ln w="7620">
+            <a:solidFill>
+              <a:srgbClr val="D8E2E7"/>
+            </a:solidFill>
+          </a:ln>
+        </p:spPr>
+        <p:style>
+          <a:lnRef idx="1">
+            <a:schemeClr val="accent1"/>
+          </a:lnRef>
+          <a:fillRef idx="3">
+            <a:schemeClr val="accent1"/>
+          </a:fillRef>
+          <a:effectRef idx="2">
+            <a:schemeClr val="accent1"/>
+          </a:effectRef>
+          <a:fontRef idx="minor">
+            <a:schemeClr val="lt1"/>
+          </a:fontRef>
+        </p:style>
+        <p:txBody>
+          <a:bodyPr rtlCol="0" anchor="ctr"/>
+          <a:lstStyle/>
+          <a:p>
+            <a:pPr algn="ctr"/>
+          </a:p>
+        </p:txBody>
+      </p:sp>
+      <p:sp>
+        <p:nvSpPr>
+          <p:cNvPr id="40" name="TextBox 39"/>
+          <p:cNvSpPr txBox="1"/>
+          <p:nvPr/>
+        </p:nvSpPr>
+        <p:spPr>
+          <a:xfrm>
+            <a:off x="9006840" y="3511296"/>
+            <a:ext cx="2487168" cy="283464"/>
+          </a:xfrm>
+          <a:prstGeom prst="rect">
+            <a:avLst/>
+          </a:prstGeom>
+          <a:noFill/>
+        </p:spPr>
+        <p:txBody>
+          <a:bodyPr wrap="square" anchor="ctr" lIns="18288" rIns="18288" tIns="18288" bIns="18288">
+            <a:spAutoFit/>
+          </a:bodyPr>
+          <a:lstStyle/>
+          <a:p>
+            <a:pPr algn="ctr">
+              <a:spcAft>
+                <a:spcPts val="500"/>
+              </a:spcAft>
+              <a:defRPr sz="1500" b="0">
+                <a:solidFill>
+                  <a:srgbClr val="556373"/>
+                </a:solidFill>
+                <a:latin typeface="Liberation Sans"/>
+              </a:defRPr>
+            </a:pPr>
+            <a:r>
+              <a:t>en integración</a:t>
+            </a:r>
+          </a:p>
+        </p:txBody>
+      </p:sp>
+      <p:sp>
+        <p:nvSpPr>
+          <p:cNvPr id="41" name="Rectangle 40"/>
+          <p:cNvSpPr/>
+          <p:nvPr/>
+        </p:nvSpPr>
+        <p:spPr>
+          <a:xfrm>
+            <a:off x="749808" y="3867912"/>
+            <a:ext cx="2615184" cy="429768"/>
+          </a:xfrm>
+          <a:prstGeom prst="rect">
+            <a:avLst/>
+          </a:prstGeom>
+          <a:solidFill>
+            <a:srgbClr val="E8F7FA"/>
+          </a:solidFill>
+          <a:ln w="7620">
+            <a:solidFill>
+              <a:srgbClr val="D8E2E7"/>
+            </a:solidFill>
+          </a:ln>
+        </p:spPr>
+        <p:style>
+          <a:lnRef idx="1">
+            <a:schemeClr val="accent1"/>
+          </a:lnRef>
+          <a:fillRef idx="3">
+            <a:schemeClr val="accent1"/>
+          </a:fillRef>
+          <a:effectRef idx="2">
+            <a:schemeClr val="accent1"/>
+          </a:effectRef>
+          <a:fontRef idx="minor">
+            <a:schemeClr val="lt1"/>
+          </a:fontRef>
+        </p:style>
+        <p:txBody>
+          <a:bodyPr rtlCol="0" anchor="ctr"/>
+          <a:lstStyle/>
+          <a:p>
+            <a:pPr algn="ctr"/>
+          </a:p>
+        </p:txBody>
+      </p:sp>
+      <p:sp>
+        <p:nvSpPr>
+          <p:cNvPr id="42" name="TextBox 41"/>
+          <p:cNvSpPr txBox="1"/>
+          <p:nvPr/>
+        </p:nvSpPr>
+        <p:spPr>
+          <a:xfrm>
+            <a:off x="813815" y="3941064"/>
+            <a:ext cx="2487168" cy="283464"/>
+          </a:xfrm>
+          <a:prstGeom prst="rect">
+            <a:avLst/>
+          </a:prstGeom>
+          <a:noFill/>
+        </p:spPr>
+        <p:txBody>
+          <a:bodyPr wrap="square" anchor="ctr" lIns="18288" rIns="18288" tIns="18288" bIns="18288">
+            <a:spAutoFit/>
+          </a:bodyPr>
+          <a:lstStyle/>
+          <a:p>
+            <a:pPr algn="ctr">
+              <a:spcAft>
+                <a:spcPts val="500"/>
+              </a:spcAft>
+              <a:defRPr sz="1700" b="1">
+                <a:solidFill>
+                  <a:srgbClr val="2D3748"/>
+                </a:solidFill>
+                <a:latin typeface="Liberation Sans"/>
+              </a:defRPr>
+            </a:pPr>
+            <a:r>
+              <a:t>Merma esperada</a:t>
+            </a:r>
+          </a:p>
+        </p:txBody>
+      </p:sp>
+      <p:sp>
+        <p:nvSpPr>
+          <p:cNvPr id="43" name="Rectangle 42"/>
+          <p:cNvSpPr/>
+          <p:nvPr/>
+        </p:nvSpPr>
+        <p:spPr>
+          <a:xfrm>
+            <a:off x="3364991" y="3867912"/>
+            <a:ext cx="2962656" cy="429768"/>
+          </a:xfrm>
+          <a:prstGeom prst="rect">
+            <a:avLst/>
+          </a:prstGeom>
+          <a:solidFill>
+            <a:srgbClr val="E8F7FA"/>
+          </a:solidFill>
+          <a:ln w="7620">
+            <a:solidFill>
+              <a:srgbClr val="D8E2E7"/>
+            </a:solidFill>
+          </a:ln>
+        </p:spPr>
+        <p:style>
+          <a:lnRef idx="1">
+            <a:schemeClr val="accent1"/>
+          </a:lnRef>
+          <a:fillRef idx="3">
+            <a:schemeClr val="accent1"/>
+          </a:fillRef>
+          <a:effectRef idx="2">
+            <a:schemeClr val="accent1"/>
+          </a:effectRef>
+          <a:fontRef idx="minor">
+            <a:schemeClr val="lt1"/>
+          </a:fontRef>
+        </p:style>
+        <p:txBody>
+          <a:bodyPr rtlCol="0" anchor="ctr"/>
+          <a:lstStyle/>
+          <a:p>
+            <a:pPr algn="ctr"/>
+          </a:p>
+        </p:txBody>
+      </p:sp>
+      <p:sp>
+        <p:nvSpPr>
+          <p:cNvPr id="44" name="TextBox 43"/>
+          <p:cNvSpPr txBox="1"/>
+          <p:nvPr/>
+        </p:nvSpPr>
+        <p:spPr>
+          <a:xfrm>
+            <a:off x="3428999" y="3941064"/>
+            <a:ext cx="2834640" cy="283464"/>
+          </a:xfrm>
+          <a:prstGeom prst="rect">
+            <a:avLst/>
+          </a:prstGeom>
+          <a:noFill/>
+        </p:spPr>
+        <p:txBody>
+          <a:bodyPr wrap="square" anchor="ctr" lIns="18288" rIns="18288" tIns="18288" bIns="18288">
+            <a:spAutoFit/>
+          </a:bodyPr>
+          <a:lstStyle/>
+          <a:p>
+            <a:pPr algn="ctr">
+              <a:spcAft>
+                <a:spcPts val="500"/>
+              </a:spcAft>
+              <a:defRPr sz="1800" b="1">
+                <a:solidFill>
+                  <a:srgbClr val="2D3748"/>
+                </a:solidFill>
+                <a:latin typeface="Liberation Sans"/>
+              </a:defRPr>
+            </a:pPr>
+            <a:r>
+              <a:t>USD 3,50</a:t>
+            </a:r>
+          </a:p>
+        </p:txBody>
+      </p:sp>
+      <p:sp>
+        <p:nvSpPr>
+          <p:cNvPr id="45" name="Rectangle 44"/>
+          <p:cNvSpPr/>
+          <p:nvPr/>
+        </p:nvSpPr>
+        <p:spPr>
+          <a:xfrm>
+            <a:off x="6327648" y="3867912"/>
+            <a:ext cx="2615184" cy="429768"/>
+          </a:xfrm>
+          <a:prstGeom prst="rect">
+            <a:avLst/>
+          </a:prstGeom>
+          <a:solidFill>
+            <a:srgbClr val="E8F7FA"/>
+          </a:solidFill>
+          <a:ln w="7620">
+            <a:solidFill>
+              <a:srgbClr val="D8E2E7"/>
+            </a:solidFill>
+          </a:ln>
+        </p:spPr>
+        <p:style>
+          <a:lnRef idx="1">
+            <a:schemeClr val="accent1"/>
+          </a:lnRef>
+          <a:fillRef idx="3">
+            <a:schemeClr val="accent1"/>
+          </a:fillRef>
+          <a:effectRef idx="2">
+            <a:schemeClr val="accent1"/>
+          </a:effectRef>
+          <a:fontRef idx="minor">
+            <a:schemeClr val="lt1"/>
+          </a:fontRef>
+        </p:style>
+        <p:txBody>
+          <a:bodyPr rtlCol="0" anchor="ctr"/>
+          <a:lstStyle/>
+          <a:p>
+            <a:pPr algn="ctr"/>
+          </a:p>
+        </p:txBody>
+      </p:sp>
+      <p:sp>
+        <p:nvSpPr>
+          <p:cNvPr id="46" name="TextBox 45"/>
+          <p:cNvSpPr txBox="1"/>
+          <p:nvPr/>
+        </p:nvSpPr>
+        <p:spPr>
+          <a:xfrm>
+            <a:off x="6391656" y="3941064"/>
+            <a:ext cx="2487168" cy="283464"/>
+          </a:xfrm>
+          <a:prstGeom prst="rect">
+            <a:avLst/>
+          </a:prstGeom>
+          <a:noFill/>
+        </p:spPr>
+        <p:txBody>
+          <a:bodyPr wrap="square" anchor="ctr" lIns="18288" rIns="18288" tIns="18288" bIns="18288">
+            <a:spAutoFit/>
+          </a:bodyPr>
+          <a:lstStyle/>
+          <a:p>
+            <a:pPr algn="ctr">
+              <a:spcAft>
+                <a:spcPts val="500"/>
+              </a:spcAft>
+              <a:defRPr sz="1500" b="0">
+                <a:solidFill>
+                  <a:srgbClr val="556373"/>
+                </a:solidFill>
+                <a:latin typeface="Liberation Sans"/>
+              </a:defRPr>
+            </a:pPr>
+            <a:r>
+              <a:t>en integración</a:t>
+            </a:r>
+          </a:p>
+        </p:txBody>
+      </p:sp>
+      <p:sp>
+        <p:nvSpPr>
+          <p:cNvPr id="47" name="Rectangle 46"/>
+          <p:cNvSpPr/>
+          <p:nvPr/>
+        </p:nvSpPr>
+        <p:spPr>
+          <a:xfrm>
+            <a:off x="8942832" y="3867912"/>
+            <a:ext cx="2615184" cy="429768"/>
+          </a:xfrm>
+          <a:prstGeom prst="rect">
+            <a:avLst/>
+          </a:prstGeom>
+          <a:solidFill>
+            <a:srgbClr val="E8F7FA"/>
+          </a:solidFill>
+          <a:ln w="7620">
+            <a:solidFill>
+              <a:srgbClr val="D8E2E7"/>
+            </a:solidFill>
+          </a:ln>
+        </p:spPr>
+        <p:style>
+          <a:lnRef idx="1">
+            <a:schemeClr val="accent1"/>
+          </a:lnRef>
+          <a:fillRef idx="3">
+            <a:schemeClr val="accent1"/>
+          </a:fillRef>
+          <a:effectRef idx="2">
+            <a:schemeClr val="accent1"/>
+          </a:effectRef>
+          <a:fontRef idx="minor">
+            <a:schemeClr val="lt1"/>
+          </a:fontRef>
+        </p:style>
+        <p:txBody>
+          <a:bodyPr rtlCol="0" anchor="ctr"/>
+          <a:lstStyle/>
+          <a:p>
+            <a:pPr algn="ctr"/>
+          </a:p>
+        </p:txBody>
+      </p:sp>
+      <p:sp>
+        <p:nvSpPr>
+          <p:cNvPr id="48" name="TextBox 47"/>
+          <p:cNvSpPr txBox="1"/>
+          <p:nvPr/>
+        </p:nvSpPr>
+        <p:spPr>
+          <a:xfrm>
+            <a:off x="9006840" y="3941064"/>
+            <a:ext cx="2487168" cy="283464"/>
+          </a:xfrm>
+          <a:prstGeom prst="rect">
+            <a:avLst/>
+          </a:prstGeom>
+          <a:noFill/>
+        </p:spPr>
+        <p:txBody>
+          <a:bodyPr wrap="square" anchor="ctr" lIns="18288" rIns="18288" tIns="18288" bIns="18288">
+            <a:spAutoFit/>
+          </a:bodyPr>
+          <a:lstStyle/>
+          <a:p>
+            <a:pPr algn="ctr">
+              <a:spcAft>
+                <a:spcPts val="500"/>
+              </a:spcAft>
+              <a:defRPr sz="1500" b="0">
+                <a:solidFill>
+                  <a:srgbClr val="556373"/>
+                </a:solidFill>
+                <a:latin typeface="Liberation Sans"/>
+              </a:defRPr>
+            </a:pPr>
+            <a:r>
+              <a:t>en integración</a:t>
+            </a:r>
+          </a:p>
+        </p:txBody>
+      </p:sp>
+      <p:sp>
+        <p:nvSpPr>
+          <p:cNvPr id="49" name="Rectangle 48"/>
+          <p:cNvSpPr/>
+          <p:nvPr/>
+        </p:nvSpPr>
+        <p:spPr>
+          <a:xfrm>
+            <a:off x="749808" y="4297680"/>
+            <a:ext cx="2615184" cy="429768"/>
+          </a:xfrm>
+          <a:prstGeom prst="rect">
+            <a:avLst/>
+          </a:prstGeom>
+          <a:solidFill>
+            <a:srgbClr val="F4F8E3"/>
+          </a:solidFill>
+          <a:ln w="7620">
+            <a:solidFill>
+              <a:srgbClr val="D8E2E7"/>
+            </a:solidFill>
+          </a:ln>
+        </p:spPr>
+        <p:style>
+          <a:lnRef idx="1">
+            <a:schemeClr val="accent1"/>
+          </a:lnRef>
+          <a:fillRef idx="3">
+            <a:schemeClr val="accent1"/>
+          </a:fillRef>
+          <a:effectRef idx="2">
+            <a:schemeClr val="accent1"/>
+          </a:effectRef>
+          <a:fontRef idx="minor">
+            <a:schemeClr val="lt1"/>
+          </a:fontRef>
+        </p:style>
+        <p:txBody>
+          <a:bodyPr rtlCol="0" anchor="ctr"/>
+          <a:lstStyle/>
+          <a:p>
+            <a:pPr algn="ctr"/>
+          </a:p>
+        </p:txBody>
+      </p:sp>
+      <p:sp>
+        <p:nvSpPr>
+          <p:cNvPr id="50" name="TextBox 49"/>
+          <p:cNvSpPr txBox="1"/>
+          <p:nvPr/>
+        </p:nvSpPr>
+        <p:spPr>
+          <a:xfrm>
+            <a:off x="813815" y="4370832"/>
+            <a:ext cx="2487168" cy="283464"/>
+          </a:xfrm>
+          <a:prstGeom prst="rect">
+            <a:avLst/>
+          </a:prstGeom>
+          <a:noFill/>
+        </p:spPr>
+        <p:txBody>
+          <a:bodyPr wrap="square" anchor="ctr" lIns="18288" rIns="18288" tIns="18288" bIns="18288">
+            <a:spAutoFit/>
+          </a:bodyPr>
+          <a:lstStyle/>
+          <a:p>
+            <a:pPr algn="ctr">
+              <a:spcAft>
+                <a:spcPts val="500"/>
+              </a:spcAft>
+              <a:defRPr sz="1700" b="1">
+                <a:solidFill>
+                  <a:srgbClr val="2D3748"/>
+                </a:solidFill>
+                <a:latin typeface="Liberation Sans"/>
+              </a:defRPr>
+            </a:pPr>
+            <a:r>
+              <a:t>Costo total</a:t>
+            </a:r>
+          </a:p>
+        </p:txBody>
+      </p:sp>
+      <p:sp>
+        <p:nvSpPr>
+          <p:cNvPr id="51" name="Rectangle 50"/>
+          <p:cNvSpPr/>
+          <p:nvPr/>
+        </p:nvSpPr>
+        <p:spPr>
+          <a:xfrm>
+            <a:off x="3364991" y="4297680"/>
+            <a:ext cx="2962656" cy="429768"/>
+          </a:xfrm>
+          <a:prstGeom prst="rect">
+            <a:avLst/>
+          </a:prstGeom>
+          <a:solidFill>
+            <a:srgbClr val="F4F8E3"/>
+          </a:solidFill>
+          <a:ln w="7620">
+            <a:solidFill>
+              <a:srgbClr val="D8E2E7"/>
+            </a:solidFill>
+          </a:ln>
+        </p:spPr>
+        <p:style>
+          <a:lnRef idx="1">
+            <a:schemeClr val="accent1"/>
+          </a:lnRef>
+          <a:fillRef idx="3">
+            <a:schemeClr val="accent1"/>
+          </a:fillRef>
+          <a:effectRef idx="2">
+            <a:schemeClr val="accent1"/>
+          </a:effectRef>
+          <a:fontRef idx="minor">
+            <a:schemeClr val="lt1"/>
+          </a:fontRef>
+        </p:style>
+        <p:txBody>
+          <a:bodyPr rtlCol="0" anchor="ctr"/>
+          <a:lstStyle/>
+          <a:p>
+            <a:pPr algn="ctr"/>
+          </a:p>
+        </p:txBody>
+      </p:sp>
+      <p:sp>
+        <p:nvSpPr>
+          <p:cNvPr id="52" name="TextBox 51"/>
+          <p:cNvSpPr txBox="1"/>
+          <p:nvPr/>
+        </p:nvSpPr>
+        <p:spPr>
+          <a:xfrm>
+            <a:off x="3428999" y="4370832"/>
+            <a:ext cx="2834640" cy="283464"/>
+          </a:xfrm>
+          <a:prstGeom prst="rect">
+            <a:avLst/>
+          </a:prstGeom>
+          <a:noFill/>
+        </p:spPr>
+        <p:txBody>
+          <a:bodyPr wrap="square" anchor="ctr" lIns="18288" rIns="18288" tIns="18288" bIns="18288">
+            <a:spAutoFit/>
+          </a:bodyPr>
+          <a:lstStyle/>
+          <a:p>
+            <a:pPr algn="ctr">
+              <a:spcAft>
+                <a:spcPts val="500"/>
+              </a:spcAft>
+              <a:defRPr sz="1900" b="1">
+                <a:solidFill>
+                  <a:srgbClr val="2D3748"/>
+                </a:solidFill>
+                <a:latin typeface="Liberation Sans"/>
+              </a:defRPr>
+            </a:pPr>
+            <a:r>
+              <a:t>USD 19,94</a:t>
+            </a:r>
+          </a:p>
+        </p:txBody>
+      </p:sp>
+      <p:sp>
+        <p:nvSpPr>
+          <p:cNvPr id="53" name="Rectangle 52"/>
+          <p:cNvSpPr/>
+          <p:nvPr/>
+        </p:nvSpPr>
+        <p:spPr>
+          <a:xfrm>
+            <a:off x="6327648" y="4297680"/>
+            <a:ext cx="2615184" cy="429768"/>
+          </a:xfrm>
+          <a:prstGeom prst="rect">
+            <a:avLst/>
+          </a:prstGeom>
+          <a:solidFill>
+            <a:srgbClr val="F4F8E3"/>
+          </a:solidFill>
+          <a:ln w="7620">
+            <a:solidFill>
+              <a:srgbClr val="D8E2E7"/>
+            </a:solidFill>
+          </a:ln>
+        </p:spPr>
+        <p:style>
+          <a:lnRef idx="1">
+            <a:schemeClr val="accent1"/>
+          </a:lnRef>
+          <a:fillRef idx="3">
+            <a:schemeClr val="accent1"/>
+          </a:fillRef>
+          <a:effectRef idx="2">
+            <a:schemeClr val="accent1"/>
+          </a:effectRef>
+          <a:fontRef idx="minor">
+            <a:schemeClr val="lt1"/>
+          </a:fontRef>
+        </p:style>
+        <p:txBody>
+          <a:bodyPr rtlCol="0" anchor="ctr"/>
+          <a:lstStyle/>
+          <a:p>
+            <a:pPr algn="ctr"/>
+          </a:p>
+        </p:txBody>
+      </p:sp>
+      <p:sp>
+        <p:nvSpPr>
+          <p:cNvPr id="54" name="TextBox 53"/>
+          <p:cNvSpPr txBox="1"/>
+          <p:nvPr/>
+        </p:nvSpPr>
+        <p:spPr>
+          <a:xfrm>
+            <a:off x="6391656" y="4370832"/>
+            <a:ext cx="2487168" cy="283464"/>
+          </a:xfrm>
+          <a:prstGeom prst="rect">
+            <a:avLst/>
+          </a:prstGeom>
+          <a:noFill/>
+        </p:spPr>
+        <p:txBody>
+          <a:bodyPr wrap="square" anchor="ctr" lIns="18288" rIns="18288" tIns="18288" bIns="18288">
+            <a:spAutoFit/>
+          </a:bodyPr>
+          <a:lstStyle/>
+          <a:p>
+            <a:pPr algn="ctr">
+              <a:spcAft>
+                <a:spcPts val="500"/>
+              </a:spcAft>
+              <a:defRPr sz="1500" b="0">
+                <a:solidFill>
+                  <a:srgbClr val="556373"/>
+                </a:solidFill>
+                <a:latin typeface="Liberation Sans"/>
+              </a:defRPr>
+            </a:pPr>
+            <a:r>
+              <a:t>en integración</a:t>
+            </a:r>
+          </a:p>
+        </p:txBody>
+      </p:sp>
+      <p:sp>
+        <p:nvSpPr>
+          <p:cNvPr id="55" name="Rectangle 54"/>
+          <p:cNvSpPr/>
+          <p:nvPr/>
+        </p:nvSpPr>
+        <p:spPr>
+          <a:xfrm>
+            <a:off x="8942832" y="4297680"/>
+            <a:ext cx="2615184" cy="429768"/>
+          </a:xfrm>
+          <a:prstGeom prst="rect">
+            <a:avLst/>
+          </a:prstGeom>
+          <a:solidFill>
+            <a:srgbClr val="F4F8E3"/>
+          </a:solidFill>
+          <a:ln w="7620">
+            <a:solidFill>
+              <a:srgbClr val="D8E2E7"/>
+            </a:solidFill>
+          </a:ln>
+        </p:spPr>
+        <p:style>
+          <a:lnRef idx="1">
+            <a:schemeClr val="accent1"/>
+          </a:lnRef>
+          <a:fillRef idx="3">
+            <a:schemeClr val="accent1"/>
+          </a:fillRef>
+          <a:effectRef idx="2">
+            <a:schemeClr val="accent1"/>
+          </a:effectRef>
+          <a:fontRef idx="minor">
+            <a:schemeClr val="lt1"/>
+          </a:fontRef>
+        </p:style>
+        <p:txBody>
+          <a:bodyPr rtlCol="0" anchor="ctr"/>
+          <a:lstStyle/>
+          <a:p>
+            <a:pPr algn="ctr"/>
+          </a:p>
+        </p:txBody>
+      </p:sp>
+      <p:sp>
+        <p:nvSpPr>
+          <p:cNvPr id="56" name="TextBox 55"/>
+          <p:cNvSpPr txBox="1"/>
+          <p:nvPr/>
+        </p:nvSpPr>
+        <p:spPr>
+          <a:xfrm>
+            <a:off x="9006840" y="4370832"/>
+            <a:ext cx="2487168" cy="283464"/>
+          </a:xfrm>
+          <a:prstGeom prst="rect">
+            <a:avLst/>
+          </a:prstGeom>
+          <a:noFill/>
+        </p:spPr>
+        <p:txBody>
+          <a:bodyPr wrap="square" anchor="ctr" lIns="18288" rIns="18288" tIns="18288" bIns="18288">
+            <a:spAutoFit/>
+          </a:bodyPr>
+          <a:lstStyle/>
+          <a:p>
+            <a:pPr algn="ctr">
+              <a:spcAft>
+                <a:spcPts val="500"/>
+              </a:spcAft>
+              <a:defRPr sz="1500" b="0">
+                <a:solidFill>
+                  <a:srgbClr val="556373"/>
+                </a:solidFill>
+                <a:latin typeface="Liberation Sans"/>
+              </a:defRPr>
+            </a:pPr>
+            <a:r>
+              <a:t>en integración</a:t>
+            </a:r>
+          </a:p>
+        </p:txBody>
+      </p:sp>
+      <p:sp>
+        <p:nvSpPr>
+          <p:cNvPr id="57" name="Rounded Rectangle 56"/>
+          <p:cNvSpPr/>
+          <p:nvPr/>
+        </p:nvSpPr>
+        <p:spPr>
+          <a:xfrm>
+            <a:off x="749808" y="4846320"/>
+            <a:ext cx="10808208" cy="658368"/>
+          </a:xfrm>
+          <a:prstGeom prst="roundRect">
+            <a:avLst/>
+          </a:prstGeom>
+          <a:solidFill>
+            <a:srgbClr val="F4F8FA"/>
+          </a:solidFill>
+          <a:ln w="12700">
+            <a:solidFill>
+              <a:srgbClr val="D8E2E7"/>
+            </a:solidFill>
+          </a:ln>
+        </p:spPr>
+        <p:style>
+          <a:lnRef idx="1">
+            <a:schemeClr val="accent1"/>
+          </a:lnRef>
+          <a:fillRef idx="3">
+            <a:schemeClr val="accent1"/>
+          </a:fillRef>
+          <a:effectRef idx="2">
+            <a:schemeClr val="accent1"/>
+          </a:effectRef>
+          <a:fontRef idx="minor">
+            <a:schemeClr val="lt1"/>
+          </a:fontRef>
+        </p:style>
+        <p:txBody>
+          <a:bodyPr rtlCol="0" anchor="ctr"/>
+          <a:lstStyle/>
+          <a:p>
+            <a:pPr algn="ctr"/>
+          </a:p>
+        </p:txBody>
+      </p:sp>
+      <p:sp>
+        <p:nvSpPr>
+          <p:cNvPr id="58" name="TextBox 57"/>
+          <p:cNvSpPr txBox="1"/>
+          <p:nvPr/>
+        </p:nvSpPr>
+        <p:spPr>
+          <a:xfrm>
+            <a:off x="914400" y="4882896"/>
+            <a:ext cx="10469880" cy="585216"/>
+          </a:xfrm>
+          <a:prstGeom prst="rect">
+            <a:avLst/>
+          </a:prstGeom>
+          <a:noFill/>
+        </p:spPr>
+        <p:txBody>
+          <a:bodyPr wrap="square" anchor="ctr" lIns="18288" rIns="18288" tIns="18288" bIns="18288">
+            <a:spAutoFit/>
+          </a:bodyPr>
+          <a:lstStyle/>
+          <a:p>
+            <a:pPr algn="ctr">
+              <a:spcAft>
+                <a:spcPts val="500"/>
+              </a:spcAft>
+              <a:defRPr sz="1700" b="0">
+                <a:solidFill>
+                  <a:srgbClr val="2D3748"/>
+                </a:solidFill>
+                <a:latin typeface="Liberation Sans"/>
+              </a:defRPr>
+            </a:pPr>
+            <a:r>
+              <a:t>«El costo de una ruta no es solo kilómetros: sumamos combustible según carga, personas que descargan y merma esperada».</a:t>
+            </a:r>
+          </a:p>
+        </p:txBody>
+      </p:sp>
+      <p:sp>
+        <p:nvSpPr>
+          <p:cNvPr id="59" name="Rounded Rectangle 58"/>
+          <p:cNvSpPr/>
+          <p:nvPr/>
+        </p:nvSpPr>
+        <p:spPr>
+          <a:xfrm>
+            <a:off x="749808" y="5577840"/>
+            <a:ext cx="6967728" cy="585216"/>
           </a:xfrm>
           <a:prstGeom prst="roundRect">
             <a:avLst/>
@@ -5705,98 +7889,14 @@
       </p:sp>
       <p:sp>
         <p:nvSpPr>
-          <p:cNvPr id="8" name="TextBox 7"/>
+          <p:cNvPr id="60" name="TextBox 59"/>
           <p:cNvSpPr txBox="1"/>
           <p:nvPr/>
         </p:nvSpPr>
         <p:spPr>
           <a:xfrm>
-            <a:off x="877824" y="1554480"/>
-            <a:ext cx="10424160" cy="274320"/>
-          </a:xfrm>
-          <a:prstGeom prst="rect">
-            <a:avLst/>
-          </a:prstGeom>
-          <a:noFill/>
-        </p:spPr>
-        <p:txBody>
-          <a:bodyPr wrap="square" anchor="t" lIns="18288" rIns="18288" tIns="18288" bIns="18288">
-            <a:spAutoFit/>
-          </a:bodyPr>
-          <a:lstStyle/>
-          <a:p>
-            <a:pPr algn="ctr">
-              <a:spcAft>
-                <a:spcPts val="500"/>
-              </a:spcAft>
-              <a:defRPr sz="1600" b="1">
-                <a:solidFill>
-                  <a:srgbClr val="2D3748"/>
-                </a:solidFill>
-                <a:latin typeface="Liberation Sans"/>
-              </a:defRPr>
-            </a:pPr>
-            <a:r>
-              <a:t>DISEÑO · comparación contratada y recomendación calculada siguen en integración</a:t>
-            </a:r>
-          </a:p>
-        </p:txBody>
-      </p:sp>
-      <p:sp>
-        <p:nvSpPr>
-          <p:cNvPr id="9" name="Rectangle 8"/>
-          <p:cNvSpPr/>
-          <p:nvPr/>
-        </p:nvSpPr>
-        <p:spPr>
-          <a:xfrm>
-            <a:off x="749808" y="2121408"/>
-            <a:ext cx="2249424" cy="603504"/>
-          </a:xfrm>
-          <a:prstGeom prst="rect">
-            <a:avLst/>
-          </a:prstGeom>
-          <a:solidFill>
-            <a:srgbClr val="00A7C4"/>
-          </a:solidFill>
-          <a:ln w="12700">
-            <a:solidFill>
-              <a:srgbClr val="00A7C4"/>
-            </a:solidFill>
-          </a:ln>
-        </p:spPr>
-        <p:style>
-          <a:lnRef idx="1">
-            <a:schemeClr val="accent1"/>
-          </a:lnRef>
-          <a:fillRef idx="3">
-            <a:schemeClr val="accent1"/>
-          </a:fillRef>
-          <a:effectRef idx="2">
-            <a:schemeClr val="accent1"/>
-          </a:effectRef>
-          <a:fontRef idx="minor">
-            <a:schemeClr val="lt1"/>
-          </a:fontRef>
-        </p:style>
-        <p:txBody>
-          <a:bodyPr rtlCol="0" anchor="ctr"/>
-          <a:lstStyle/>
-          <a:p>
-            <a:pPr algn="ctr"/>
-          </a:p>
-        </p:txBody>
-      </p:sp>
-      <p:sp>
-        <p:nvSpPr>
-          <p:cNvPr id="10" name="TextBox 9"/>
-          <p:cNvSpPr txBox="1"/>
-          <p:nvPr/>
-        </p:nvSpPr>
-        <p:spPr>
-          <a:xfrm>
-            <a:off x="813815" y="2231136"/>
-            <a:ext cx="2121408" cy="384048"/>
+            <a:off x="896112" y="5614416"/>
+            <a:ext cx="6675120" cy="512064"/>
           </a:xfrm>
           <a:prstGeom prst="rect">
             <a:avLst/>
@@ -5809,2139 +7909,39 @@
           </a:bodyPr>
           <a:lstStyle/>
           <a:p>
-            <a:pPr algn="ctr">
+            <a:pPr algn="l">
               <a:spcAft>
                 <a:spcPts val="500"/>
               </a:spcAft>
               <a:defRPr sz="1500" b="1">
                 <a:solidFill>
-                  <a:srgbClr val="FFFFFF"/>
+                  <a:srgbClr val="2D3748"/>
                 </a:solidFill>
                 <a:latin typeface="Liberation Sans"/>
               </a:defRPr>
             </a:pPr>
             <a:r>
-              <a:t>Componente</a:t>
-            </a:r>
-          </a:p>
-        </p:txBody>
-      </p:sp>
-      <p:sp>
-        <p:nvSpPr>
-          <p:cNvPr id="11" name="Rectangle 10"/>
+              <a:t>La comparación con operador contratado y la recomendación calculada se integran en #241.</a:t>
+            </a:r>
+          </a:p>
+        </p:txBody>
+      </p:sp>
+      <p:sp>
+        <p:nvSpPr>
+          <p:cNvPr id="61" name="Rounded Rectangle 60"/>
           <p:cNvSpPr/>
           <p:nvPr/>
         </p:nvSpPr>
         <p:spPr>
           <a:xfrm>
-            <a:off x="2999232" y="2121408"/>
-            <a:ext cx="2304288" cy="603504"/>
-          </a:xfrm>
-          <a:prstGeom prst="rect">
-            <a:avLst/>
-          </a:prstGeom>
-          <a:solidFill>
-            <a:srgbClr val="2D3748"/>
-          </a:solidFill>
-          <a:ln w="12700">
-            <a:solidFill>
-              <a:srgbClr val="2D3748"/>
-            </a:solidFill>
-          </a:ln>
-        </p:spPr>
-        <p:style>
-          <a:lnRef idx="1">
-            <a:schemeClr val="accent1"/>
-          </a:lnRef>
-          <a:fillRef idx="3">
-            <a:schemeClr val="accent1"/>
-          </a:fillRef>
-          <a:effectRef idx="2">
-            <a:schemeClr val="accent1"/>
-          </a:effectRef>
-          <a:fontRef idx="minor">
-            <a:schemeClr val="lt1"/>
-          </a:fontRef>
-        </p:style>
-        <p:txBody>
-          <a:bodyPr rtlCol="0" anchor="ctr"/>
-          <a:lstStyle/>
-          <a:p>
-            <a:pPr algn="ctr"/>
-          </a:p>
-        </p:txBody>
-      </p:sp>
-      <p:sp>
-        <p:nvSpPr>
-          <p:cNvPr id="12" name="TextBox 11"/>
-          <p:cNvSpPr txBox="1"/>
-          <p:nvPr/>
-        </p:nvSpPr>
-        <p:spPr>
-          <a:xfrm>
-            <a:off x="3063239" y="2231136"/>
-            <a:ext cx="2176272" cy="384048"/>
-          </a:xfrm>
-          <a:prstGeom prst="rect">
-            <a:avLst/>
-          </a:prstGeom>
-          <a:noFill/>
-        </p:spPr>
-        <p:txBody>
-          <a:bodyPr wrap="square" anchor="ctr" lIns="18288" rIns="18288" tIns="18288" bIns="18288">
-            <a:spAutoFit/>
-          </a:bodyPr>
-          <a:lstStyle/>
-          <a:p>
-            <a:pPr algn="ctr">
-              <a:spcAft>
-                <a:spcPts val="500"/>
-              </a:spcAft>
-              <a:defRPr sz="1500" b="1">
-                <a:solidFill>
-                  <a:srgbClr val="FFFFFF"/>
-                </a:solidFill>
-                <a:latin typeface="Liberation Sans"/>
-              </a:defRPr>
-            </a:pPr>
-            <a:r>
-              <a:t>A · Flota propia</a:t>
-            </a:r>
-          </a:p>
-        </p:txBody>
-      </p:sp>
-      <p:sp>
-        <p:nvSpPr>
-          <p:cNvPr id="13" name="Rectangle 12"/>
-          <p:cNvSpPr/>
-          <p:nvPr/>
-        </p:nvSpPr>
-        <p:spPr>
-          <a:xfrm>
-            <a:off x="5303520" y="2121408"/>
-            <a:ext cx="2304288" cy="603504"/>
-          </a:xfrm>
-          <a:prstGeom prst="rect">
-            <a:avLst/>
-          </a:prstGeom>
-          <a:solidFill>
-            <a:srgbClr val="2D3748"/>
-          </a:solidFill>
-          <a:ln w="12700">
-            <a:solidFill>
-              <a:srgbClr val="2D3748"/>
-            </a:solidFill>
-          </a:ln>
-        </p:spPr>
-        <p:style>
-          <a:lnRef idx="1">
-            <a:schemeClr val="accent1"/>
-          </a:lnRef>
-          <a:fillRef idx="3">
-            <a:schemeClr val="accent1"/>
-          </a:fillRef>
-          <a:effectRef idx="2">
-            <a:schemeClr val="accent1"/>
-          </a:effectRef>
-          <a:fontRef idx="minor">
-            <a:schemeClr val="lt1"/>
-          </a:fontRef>
-        </p:style>
-        <p:txBody>
-          <a:bodyPr rtlCol="0" anchor="ctr"/>
-          <a:lstStyle/>
-          <a:p>
-            <a:pPr algn="ctr"/>
-          </a:p>
-        </p:txBody>
-      </p:sp>
-      <p:sp>
-        <p:nvSpPr>
-          <p:cNvPr id="14" name="TextBox 13"/>
-          <p:cNvSpPr txBox="1"/>
-          <p:nvPr/>
-        </p:nvSpPr>
-        <p:spPr>
-          <a:xfrm>
-            <a:off x="5367528" y="2231136"/>
-            <a:ext cx="2176272" cy="384048"/>
-          </a:xfrm>
-          <a:prstGeom prst="rect">
-            <a:avLst/>
-          </a:prstGeom>
-          <a:noFill/>
-        </p:spPr>
-        <p:txBody>
-          <a:bodyPr wrap="square" anchor="ctr" lIns="18288" rIns="18288" tIns="18288" bIns="18288">
-            <a:spAutoFit/>
-          </a:bodyPr>
-          <a:lstStyle/>
-          <a:p>
-            <a:pPr algn="ctr">
-              <a:spcAft>
-                <a:spcPts val="500"/>
-              </a:spcAft>
-              <a:defRPr sz="1500" b="1">
-                <a:solidFill>
-                  <a:srgbClr val="FFFFFF"/>
-                </a:solidFill>
-                <a:latin typeface="Liberation Sans"/>
-              </a:defRPr>
-            </a:pPr>
-            <a:r>
-              <a:t>B · Propia, críticos primero</a:t>
-            </a:r>
-          </a:p>
-        </p:txBody>
-      </p:sp>
-      <p:sp>
-        <p:nvSpPr>
-          <p:cNvPr id="15" name="Rectangle 14"/>
-          <p:cNvSpPr/>
-          <p:nvPr/>
-        </p:nvSpPr>
-        <p:spPr>
-          <a:xfrm>
-            <a:off x="7607808" y="2121408"/>
-            <a:ext cx="2304288" cy="603504"/>
-          </a:xfrm>
-          <a:prstGeom prst="rect">
-            <a:avLst/>
-          </a:prstGeom>
-          <a:solidFill>
-            <a:srgbClr val="2D3748"/>
-          </a:solidFill>
-          <a:ln w="12700">
-            <a:solidFill>
-              <a:srgbClr val="2D3748"/>
-            </a:solidFill>
-          </a:ln>
-        </p:spPr>
-        <p:style>
-          <a:lnRef idx="1">
-            <a:schemeClr val="accent1"/>
-          </a:lnRef>
-          <a:fillRef idx="3">
-            <a:schemeClr val="accent1"/>
-          </a:fillRef>
-          <a:effectRef idx="2">
-            <a:schemeClr val="accent1"/>
-          </a:effectRef>
-          <a:fontRef idx="minor">
-            <a:schemeClr val="lt1"/>
-          </a:fontRef>
-        </p:style>
-        <p:txBody>
-          <a:bodyPr rtlCol="0" anchor="ctr"/>
-          <a:lstStyle/>
-          <a:p>
-            <a:pPr algn="ctr"/>
-          </a:p>
-        </p:txBody>
-      </p:sp>
-      <p:sp>
-        <p:nvSpPr>
-          <p:cNvPr id="16" name="TextBox 15"/>
-          <p:cNvSpPr txBox="1"/>
-          <p:nvPr/>
-        </p:nvSpPr>
-        <p:spPr>
-          <a:xfrm>
-            <a:off x="7671816" y="2231136"/>
-            <a:ext cx="2176272" cy="384048"/>
-          </a:xfrm>
-          <a:prstGeom prst="rect">
-            <a:avLst/>
-          </a:prstGeom>
-          <a:noFill/>
-        </p:spPr>
-        <p:txBody>
-          <a:bodyPr wrap="square" anchor="ctr" lIns="18288" rIns="18288" tIns="18288" bIns="18288">
-            <a:spAutoFit/>
-          </a:bodyPr>
-          <a:lstStyle/>
-          <a:p>
-            <a:pPr algn="ctr">
-              <a:spcAft>
-                <a:spcPts val="500"/>
-              </a:spcAft>
-              <a:defRPr sz="1500" b="1">
-                <a:solidFill>
-                  <a:srgbClr val="FFFFFF"/>
-                </a:solidFill>
-                <a:latin typeface="Liberation Sans"/>
-              </a:defRPr>
-            </a:pPr>
-            <a:r>
-              <a:t>C · Contratada</a:t>
-            </a:r>
-          </a:p>
-        </p:txBody>
-      </p:sp>
-      <p:sp>
-        <p:nvSpPr>
-          <p:cNvPr id="17" name="Rectangle 16"/>
-          <p:cNvSpPr/>
-          <p:nvPr/>
-        </p:nvSpPr>
-        <p:spPr>
-          <a:xfrm>
-            <a:off x="749808" y="2724912"/>
-            <a:ext cx="2249424" cy="438912"/>
-          </a:xfrm>
-          <a:prstGeom prst="rect">
+            <a:off x="7845552" y="5577840"/>
+            <a:ext cx="3712463" cy="585216"/>
+          </a:xfrm>
+          <a:prstGeom prst="roundRect">
             <a:avLst/>
           </a:prstGeom>
           <a:solidFill>
             <a:srgbClr val="FFFFFF"/>
-          </a:solidFill>
-          <a:ln w="7620">
-            <a:solidFill>
-              <a:srgbClr val="D8E2E7"/>
-            </a:solidFill>
-          </a:ln>
-        </p:spPr>
-        <p:style>
-          <a:lnRef idx="1">
-            <a:schemeClr val="accent1"/>
-          </a:lnRef>
-          <a:fillRef idx="3">
-            <a:schemeClr val="accent1"/>
-          </a:fillRef>
-          <a:effectRef idx="2">
-            <a:schemeClr val="accent1"/>
-          </a:effectRef>
-          <a:fontRef idx="minor">
-            <a:schemeClr val="lt1"/>
-          </a:fontRef>
-        </p:style>
-        <p:txBody>
-          <a:bodyPr rtlCol="0" anchor="ctr"/>
-          <a:lstStyle/>
-          <a:p>
-            <a:pPr algn="ctr"/>
-          </a:p>
-        </p:txBody>
-      </p:sp>
-      <p:sp>
-        <p:nvSpPr>
-          <p:cNvPr id="18" name="TextBox 17"/>
-          <p:cNvSpPr txBox="1"/>
-          <p:nvPr/>
-        </p:nvSpPr>
-        <p:spPr>
-          <a:xfrm>
-            <a:off x="813815" y="2816352"/>
-            <a:ext cx="2121408" cy="246888"/>
-          </a:xfrm>
-          <a:prstGeom prst="rect">
-            <a:avLst/>
-          </a:prstGeom>
-          <a:noFill/>
-        </p:spPr>
-        <p:txBody>
-          <a:bodyPr wrap="square" anchor="ctr" lIns="18288" rIns="18288" tIns="18288" bIns="18288">
-            <a:spAutoFit/>
-          </a:bodyPr>
-          <a:lstStyle/>
-          <a:p>
-            <a:pPr algn="ctr">
-              <a:spcAft>
-                <a:spcPts val="500"/>
-              </a:spcAft>
-              <a:defRPr sz="1600" b="1">
-                <a:solidFill>
-                  <a:srgbClr val="2D3748"/>
-                </a:solidFill>
-                <a:latin typeface="Liberation Sans"/>
-              </a:defRPr>
-            </a:pPr>
-            <a:r>
-              <a:t>Combustible</a:t>
-            </a:r>
-          </a:p>
-        </p:txBody>
-      </p:sp>
-      <p:sp>
-        <p:nvSpPr>
-          <p:cNvPr id="19" name="Rectangle 18"/>
-          <p:cNvSpPr/>
-          <p:nvPr/>
-        </p:nvSpPr>
-        <p:spPr>
-          <a:xfrm>
-            <a:off x="2999232" y="2724912"/>
-            <a:ext cx="2304288" cy="438912"/>
-          </a:xfrm>
-          <a:prstGeom prst="rect">
-            <a:avLst/>
-          </a:prstGeom>
-          <a:solidFill>
-            <a:srgbClr val="FFFFFF"/>
-          </a:solidFill>
-          <a:ln w="7620">
-            <a:solidFill>
-              <a:srgbClr val="D8E2E7"/>
-            </a:solidFill>
-          </a:ln>
-        </p:spPr>
-        <p:style>
-          <a:lnRef idx="1">
-            <a:schemeClr val="accent1"/>
-          </a:lnRef>
-          <a:fillRef idx="3">
-            <a:schemeClr val="accent1"/>
-          </a:fillRef>
-          <a:effectRef idx="2">
-            <a:schemeClr val="accent1"/>
-          </a:effectRef>
-          <a:fontRef idx="minor">
-            <a:schemeClr val="lt1"/>
-          </a:fontRef>
-        </p:style>
-        <p:txBody>
-          <a:bodyPr rtlCol="0" anchor="ctr"/>
-          <a:lstStyle/>
-          <a:p>
-            <a:pPr algn="ctr"/>
-          </a:p>
-        </p:txBody>
-      </p:sp>
-      <p:sp>
-        <p:nvSpPr>
-          <p:cNvPr id="20" name="TextBox 19"/>
-          <p:cNvSpPr txBox="1"/>
-          <p:nvPr/>
-        </p:nvSpPr>
-        <p:spPr>
-          <a:xfrm>
-            <a:off x="3063239" y="2816352"/>
-            <a:ext cx="2176272" cy="246888"/>
-          </a:xfrm>
-          <a:prstGeom prst="rect">
-            <a:avLst/>
-          </a:prstGeom>
-          <a:noFill/>
-        </p:spPr>
-        <p:txBody>
-          <a:bodyPr wrap="square" anchor="ctr" lIns="18288" rIns="18288" tIns="18288" bIns="18288">
-            <a:spAutoFit/>
-          </a:bodyPr>
-          <a:lstStyle/>
-          <a:p>
-            <a:pPr algn="ctr">
-              <a:spcAft>
-                <a:spcPts val="500"/>
-              </a:spcAft>
-              <a:defRPr sz="1500" b="0">
-                <a:solidFill>
-                  <a:srgbClr val="556373"/>
-                </a:solidFill>
-                <a:latin typeface="Liberation Sans"/>
-              </a:defRPr>
-            </a:pPr>
-            <a:r>
-              <a:t>sin dato</a:t>
-            </a:r>
-          </a:p>
-        </p:txBody>
-      </p:sp>
-      <p:sp>
-        <p:nvSpPr>
-          <p:cNvPr id="21" name="Rectangle 20"/>
-          <p:cNvSpPr/>
-          <p:nvPr/>
-        </p:nvSpPr>
-        <p:spPr>
-          <a:xfrm>
-            <a:off x="5303520" y="2724912"/>
-            <a:ext cx="2304288" cy="438912"/>
-          </a:xfrm>
-          <a:prstGeom prst="rect">
-            <a:avLst/>
-          </a:prstGeom>
-          <a:solidFill>
-            <a:srgbClr val="FFFFFF"/>
-          </a:solidFill>
-          <a:ln w="7620">
-            <a:solidFill>
-              <a:srgbClr val="D8E2E7"/>
-            </a:solidFill>
-          </a:ln>
-        </p:spPr>
-        <p:style>
-          <a:lnRef idx="1">
-            <a:schemeClr val="accent1"/>
-          </a:lnRef>
-          <a:fillRef idx="3">
-            <a:schemeClr val="accent1"/>
-          </a:fillRef>
-          <a:effectRef idx="2">
-            <a:schemeClr val="accent1"/>
-          </a:effectRef>
-          <a:fontRef idx="minor">
-            <a:schemeClr val="lt1"/>
-          </a:fontRef>
-        </p:style>
-        <p:txBody>
-          <a:bodyPr rtlCol="0" anchor="ctr"/>
-          <a:lstStyle/>
-          <a:p>
-            <a:pPr algn="ctr"/>
-          </a:p>
-        </p:txBody>
-      </p:sp>
-      <p:sp>
-        <p:nvSpPr>
-          <p:cNvPr id="22" name="TextBox 21"/>
-          <p:cNvSpPr txBox="1"/>
-          <p:nvPr/>
-        </p:nvSpPr>
-        <p:spPr>
-          <a:xfrm>
-            <a:off x="5367528" y="2816352"/>
-            <a:ext cx="2176272" cy="246888"/>
-          </a:xfrm>
-          <a:prstGeom prst="rect">
-            <a:avLst/>
-          </a:prstGeom>
-          <a:noFill/>
-        </p:spPr>
-        <p:txBody>
-          <a:bodyPr wrap="square" anchor="ctr" lIns="18288" rIns="18288" tIns="18288" bIns="18288">
-            <a:spAutoFit/>
-          </a:bodyPr>
-          <a:lstStyle/>
-          <a:p>
-            <a:pPr algn="ctr">
-              <a:spcAft>
-                <a:spcPts val="500"/>
-              </a:spcAft>
-              <a:defRPr sz="1500" b="0">
-                <a:solidFill>
-                  <a:srgbClr val="556373"/>
-                </a:solidFill>
-                <a:latin typeface="Liberation Sans"/>
-              </a:defRPr>
-            </a:pPr>
-            <a:r>
-              <a:t>sin dato</a:t>
-            </a:r>
-          </a:p>
-        </p:txBody>
-      </p:sp>
-      <p:sp>
-        <p:nvSpPr>
-          <p:cNvPr id="23" name="Rectangle 22"/>
-          <p:cNvSpPr/>
-          <p:nvPr/>
-        </p:nvSpPr>
-        <p:spPr>
-          <a:xfrm>
-            <a:off x="7607808" y="2724912"/>
-            <a:ext cx="2304288" cy="438912"/>
-          </a:xfrm>
-          <a:prstGeom prst="rect">
-            <a:avLst/>
-          </a:prstGeom>
-          <a:solidFill>
-            <a:srgbClr val="FFFFFF"/>
-          </a:solidFill>
-          <a:ln w="7620">
-            <a:solidFill>
-              <a:srgbClr val="D8E2E7"/>
-            </a:solidFill>
-          </a:ln>
-        </p:spPr>
-        <p:style>
-          <a:lnRef idx="1">
-            <a:schemeClr val="accent1"/>
-          </a:lnRef>
-          <a:fillRef idx="3">
-            <a:schemeClr val="accent1"/>
-          </a:fillRef>
-          <a:effectRef idx="2">
-            <a:schemeClr val="accent1"/>
-          </a:effectRef>
-          <a:fontRef idx="minor">
-            <a:schemeClr val="lt1"/>
-          </a:fontRef>
-        </p:style>
-        <p:txBody>
-          <a:bodyPr rtlCol="0" anchor="ctr"/>
-          <a:lstStyle/>
-          <a:p>
-            <a:pPr algn="ctr"/>
-          </a:p>
-        </p:txBody>
-      </p:sp>
-      <p:sp>
-        <p:nvSpPr>
-          <p:cNvPr id="24" name="TextBox 23"/>
-          <p:cNvSpPr txBox="1"/>
-          <p:nvPr/>
-        </p:nvSpPr>
-        <p:spPr>
-          <a:xfrm>
-            <a:off x="7671816" y="2816352"/>
-            <a:ext cx="2176272" cy="246888"/>
-          </a:xfrm>
-          <a:prstGeom prst="rect">
-            <a:avLst/>
-          </a:prstGeom>
-          <a:noFill/>
-        </p:spPr>
-        <p:txBody>
-          <a:bodyPr wrap="square" anchor="ctr" lIns="18288" rIns="18288" tIns="18288" bIns="18288">
-            <a:spAutoFit/>
-          </a:bodyPr>
-          <a:lstStyle/>
-          <a:p>
-            <a:pPr algn="ctr">
-              <a:spcAft>
-                <a:spcPts val="500"/>
-              </a:spcAft>
-              <a:defRPr sz="1500" b="0">
-                <a:solidFill>
-                  <a:srgbClr val="556373"/>
-                </a:solidFill>
-                <a:latin typeface="Liberation Sans"/>
-              </a:defRPr>
-            </a:pPr>
-            <a:r>
-              <a:t>sin dato</a:t>
-            </a:r>
-          </a:p>
-        </p:txBody>
-      </p:sp>
-      <p:sp>
-        <p:nvSpPr>
-          <p:cNvPr id="25" name="Rectangle 24"/>
-          <p:cNvSpPr/>
-          <p:nvPr/>
-        </p:nvSpPr>
-        <p:spPr>
-          <a:xfrm>
-            <a:off x="749808" y="3163824"/>
-            <a:ext cx="2249424" cy="438912"/>
-          </a:xfrm>
-          <a:prstGeom prst="rect">
-            <a:avLst/>
-          </a:prstGeom>
-          <a:solidFill>
-            <a:srgbClr val="E8F7FA"/>
-          </a:solidFill>
-          <a:ln w="7620">
-            <a:solidFill>
-              <a:srgbClr val="D8E2E7"/>
-            </a:solidFill>
-          </a:ln>
-        </p:spPr>
-        <p:style>
-          <a:lnRef idx="1">
-            <a:schemeClr val="accent1"/>
-          </a:lnRef>
-          <a:fillRef idx="3">
-            <a:schemeClr val="accent1"/>
-          </a:fillRef>
-          <a:effectRef idx="2">
-            <a:schemeClr val="accent1"/>
-          </a:effectRef>
-          <a:fontRef idx="minor">
-            <a:schemeClr val="lt1"/>
-          </a:fontRef>
-        </p:style>
-        <p:txBody>
-          <a:bodyPr rtlCol="0" anchor="ctr"/>
-          <a:lstStyle/>
-          <a:p>
-            <a:pPr algn="ctr"/>
-          </a:p>
-        </p:txBody>
-      </p:sp>
-      <p:sp>
-        <p:nvSpPr>
-          <p:cNvPr id="26" name="TextBox 25"/>
-          <p:cNvSpPr txBox="1"/>
-          <p:nvPr/>
-        </p:nvSpPr>
-        <p:spPr>
-          <a:xfrm>
-            <a:off x="813815" y="3255264"/>
-            <a:ext cx="2121408" cy="246888"/>
-          </a:xfrm>
-          <a:prstGeom prst="rect">
-            <a:avLst/>
-          </a:prstGeom>
-          <a:noFill/>
-        </p:spPr>
-        <p:txBody>
-          <a:bodyPr wrap="square" anchor="ctr" lIns="18288" rIns="18288" tIns="18288" bIns="18288">
-            <a:spAutoFit/>
-          </a:bodyPr>
-          <a:lstStyle/>
-          <a:p>
-            <a:pPr algn="ctr">
-              <a:spcAft>
-                <a:spcPts val="500"/>
-              </a:spcAft>
-              <a:defRPr sz="1600" b="1">
-                <a:solidFill>
-                  <a:srgbClr val="2D3748"/>
-                </a:solidFill>
-                <a:latin typeface="Liberation Sans"/>
-              </a:defRPr>
-            </a:pPr>
-            <a:r>
-              <a:t>Desgaste</a:t>
-            </a:r>
-          </a:p>
-        </p:txBody>
-      </p:sp>
-      <p:sp>
-        <p:nvSpPr>
-          <p:cNvPr id="27" name="Rectangle 26"/>
-          <p:cNvSpPr/>
-          <p:nvPr/>
-        </p:nvSpPr>
-        <p:spPr>
-          <a:xfrm>
-            <a:off x="2999232" y="3163824"/>
-            <a:ext cx="2304288" cy="438912"/>
-          </a:xfrm>
-          <a:prstGeom prst="rect">
-            <a:avLst/>
-          </a:prstGeom>
-          <a:solidFill>
-            <a:srgbClr val="E8F7FA"/>
-          </a:solidFill>
-          <a:ln w="7620">
-            <a:solidFill>
-              <a:srgbClr val="D8E2E7"/>
-            </a:solidFill>
-          </a:ln>
-        </p:spPr>
-        <p:style>
-          <a:lnRef idx="1">
-            <a:schemeClr val="accent1"/>
-          </a:lnRef>
-          <a:fillRef idx="3">
-            <a:schemeClr val="accent1"/>
-          </a:fillRef>
-          <a:effectRef idx="2">
-            <a:schemeClr val="accent1"/>
-          </a:effectRef>
-          <a:fontRef idx="minor">
-            <a:schemeClr val="lt1"/>
-          </a:fontRef>
-        </p:style>
-        <p:txBody>
-          <a:bodyPr rtlCol="0" anchor="ctr"/>
-          <a:lstStyle/>
-          <a:p>
-            <a:pPr algn="ctr"/>
-          </a:p>
-        </p:txBody>
-      </p:sp>
-      <p:sp>
-        <p:nvSpPr>
-          <p:cNvPr id="28" name="TextBox 27"/>
-          <p:cNvSpPr txBox="1"/>
-          <p:nvPr/>
-        </p:nvSpPr>
-        <p:spPr>
-          <a:xfrm>
-            <a:off x="3063239" y="3255264"/>
-            <a:ext cx="2176272" cy="246888"/>
-          </a:xfrm>
-          <a:prstGeom prst="rect">
-            <a:avLst/>
-          </a:prstGeom>
-          <a:noFill/>
-        </p:spPr>
-        <p:txBody>
-          <a:bodyPr wrap="square" anchor="ctr" lIns="18288" rIns="18288" tIns="18288" bIns="18288">
-            <a:spAutoFit/>
-          </a:bodyPr>
-          <a:lstStyle/>
-          <a:p>
-            <a:pPr algn="ctr">
-              <a:spcAft>
-                <a:spcPts val="500"/>
-              </a:spcAft>
-              <a:defRPr sz="1500" b="0">
-                <a:solidFill>
-                  <a:srgbClr val="556373"/>
-                </a:solidFill>
-                <a:latin typeface="Liberation Sans"/>
-              </a:defRPr>
-            </a:pPr>
-            <a:r>
-              <a:t>sin dato</a:t>
-            </a:r>
-          </a:p>
-        </p:txBody>
-      </p:sp>
-      <p:sp>
-        <p:nvSpPr>
-          <p:cNvPr id="29" name="Rectangle 28"/>
-          <p:cNvSpPr/>
-          <p:nvPr/>
-        </p:nvSpPr>
-        <p:spPr>
-          <a:xfrm>
-            <a:off x="5303520" y="3163824"/>
-            <a:ext cx="2304288" cy="438912"/>
-          </a:xfrm>
-          <a:prstGeom prst="rect">
-            <a:avLst/>
-          </a:prstGeom>
-          <a:solidFill>
-            <a:srgbClr val="E8F7FA"/>
-          </a:solidFill>
-          <a:ln w="7620">
-            <a:solidFill>
-              <a:srgbClr val="D8E2E7"/>
-            </a:solidFill>
-          </a:ln>
-        </p:spPr>
-        <p:style>
-          <a:lnRef idx="1">
-            <a:schemeClr val="accent1"/>
-          </a:lnRef>
-          <a:fillRef idx="3">
-            <a:schemeClr val="accent1"/>
-          </a:fillRef>
-          <a:effectRef idx="2">
-            <a:schemeClr val="accent1"/>
-          </a:effectRef>
-          <a:fontRef idx="minor">
-            <a:schemeClr val="lt1"/>
-          </a:fontRef>
-        </p:style>
-        <p:txBody>
-          <a:bodyPr rtlCol="0" anchor="ctr"/>
-          <a:lstStyle/>
-          <a:p>
-            <a:pPr algn="ctr"/>
-          </a:p>
-        </p:txBody>
-      </p:sp>
-      <p:sp>
-        <p:nvSpPr>
-          <p:cNvPr id="30" name="TextBox 29"/>
-          <p:cNvSpPr txBox="1"/>
-          <p:nvPr/>
-        </p:nvSpPr>
-        <p:spPr>
-          <a:xfrm>
-            <a:off x="5367528" y="3255264"/>
-            <a:ext cx="2176272" cy="246888"/>
-          </a:xfrm>
-          <a:prstGeom prst="rect">
-            <a:avLst/>
-          </a:prstGeom>
-          <a:noFill/>
-        </p:spPr>
-        <p:txBody>
-          <a:bodyPr wrap="square" anchor="ctr" lIns="18288" rIns="18288" tIns="18288" bIns="18288">
-            <a:spAutoFit/>
-          </a:bodyPr>
-          <a:lstStyle/>
-          <a:p>
-            <a:pPr algn="ctr">
-              <a:spcAft>
-                <a:spcPts val="500"/>
-              </a:spcAft>
-              <a:defRPr sz="1500" b="0">
-                <a:solidFill>
-                  <a:srgbClr val="556373"/>
-                </a:solidFill>
-                <a:latin typeface="Liberation Sans"/>
-              </a:defRPr>
-            </a:pPr>
-            <a:r>
-              <a:t>sin dato</a:t>
-            </a:r>
-          </a:p>
-        </p:txBody>
-      </p:sp>
-      <p:sp>
-        <p:nvSpPr>
-          <p:cNvPr id="31" name="Rectangle 30"/>
-          <p:cNvSpPr/>
-          <p:nvPr/>
-        </p:nvSpPr>
-        <p:spPr>
-          <a:xfrm>
-            <a:off x="7607808" y="3163824"/>
-            <a:ext cx="2304288" cy="438912"/>
-          </a:xfrm>
-          <a:prstGeom prst="rect">
-            <a:avLst/>
-          </a:prstGeom>
-          <a:solidFill>
-            <a:srgbClr val="E8F7FA"/>
-          </a:solidFill>
-          <a:ln w="7620">
-            <a:solidFill>
-              <a:srgbClr val="D8E2E7"/>
-            </a:solidFill>
-          </a:ln>
-        </p:spPr>
-        <p:style>
-          <a:lnRef idx="1">
-            <a:schemeClr val="accent1"/>
-          </a:lnRef>
-          <a:fillRef idx="3">
-            <a:schemeClr val="accent1"/>
-          </a:fillRef>
-          <a:effectRef idx="2">
-            <a:schemeClr val="accent1"/>
-          </a:effectRef>
-          <a:fontRef idx="minor">
-            <a:schemeClr val="lt1"/>
-          </a:fontRef>
-        </p:style>
-        <p:txBody>
-          <a:bodyPr rtlCol="0" anchor="ctr"/>
-          <a:lstStyle/>
-          <a:p>
-            <a:pPr algn="ctr"/>
-          </a:p>
-        </p:txBody>
-      </p:sp>
-      <p:sp>
-        <p:nvSpPr>
-          <p:cNvPr id="32" name="TextBox 31"/>
-          <p:cNvSpPr txBox="1"/>
-          <p:nvPr/>
-        </p:nvSpPr>
-        <p:spPr>
-          <a:xfrm>
-            <a:off x="7671816" y="3255264"/>
-            <a:ext cx="2176272" cy="246888"/>
-          </a:xfrm>
-          <a:prstGeom prst="rect">
-            <a:avLst/>
-          </a:prstGeom>
-          <a:noFill/>
-        </p:spPr>
-        <p:txBody>
-          <a:bodyPr wrap="square" anchor="ctr" lIns="18288" rIns="18288" tIns="18288" bIns="18288">
-            <a:spAutoFit/>
-          </a:bodyPr>
-          <a:lstStyle/>
-          <a:p>
-            <a:pPr algn="ctr">
-              <a:spcAft>
-                <a:spcPts val="500"/>
-              </a:spcAft>
-              <a:defRPr sz="1500" b="0">
-                <a:solidFill>
-                  <a:srgbClr val="556373"/>
-                </a:solidFill>
-                <a:latin typeface="Liberation Sans"/>
-              </a:defRPr>
-            </a:pPr>
-            <a:r>
-              <a:t>sin dato</a:t>
-            </a:r>
-          </a:p>
-        </p:txBody>
-      </p:sp>
-      <p:sp>
-        <p:nvSpPr>
-          <p:cNvPr id="33" name="Rectangle 32"/>
-          <p:cNvSpPr/>
-          <p:nvPr/>
-        </p:nvSpPr>
-        <p:spPr>
-          <a:xfrm>
-            <a:off x="749808" y="3602736"/>
-            <a:ext cx="2249424" cy="438912"/>
-          </a:xfrm>
-          <a:prstGeom prst="rect">
-            <a:avLst/>
-          </a:prstGeom>
-          <a:solidFill>
-            <a:srgbClr val="FFFFFF"/>
-          </a:solidFill>
-          <a:ln w="7620">
-            <a:solidFill>
-              <a:srgbClr val="D8E2E7"/>
-            </a:solidFill>
-          </a:ln>
-        </p:spPr>
-        <p:style>
-          <a:lnRef idx="1">
-            <a:schemeClr val="accent1"/>
-          </a:lnRef>
-          <a:fillRef idx="3">
-            <a:schemeClr val="accent1"/>
-          </a:fillRef>
-          <a:effectRef idx="2">
-            <a:schemeClr val="accent1"/>
-          </a:effectRef>
-          <a:fontRef idx="minor">
-            <a:schemeClr val="lt1"/>
-          </a:fontRef>
-        </p:style>
-        <p:txBody>
-          <a:bodyPr rtlCol="0" anchor="ctr"/>
-          <a:lstStyle/>
-          <a:p>
-            <a:pPr algn="ctr"/>
-          </a:p>
-        </p:txBody>
-      </p:sp>
-      <p:sp>
-        <p:nvSpPr>
-          <p:cNvPr id="34" name="TextBox 33"/>
-          <p:cNvSpPr txBox="1"/>
-          <p:nvPr/>
-        </p:nvSpPr>
-        <p:spPr>
-          <a:xfrm>
-            <a:off x="813815" y="3694176"/>
-            <a:ext cx="2121408" cy="246888"/>
-          </a:xfrm>
-          <a:prstGeom prst="rect">
-            <a:avLst/>
-          </a:prstGeom>
-          <a:noFill/>
-        </p:spPr>
-        <p:txBody>
-          <a:bodyPr wrap="square" anchor="ctr" lIns="18288" rIns="18288" tIns="18288" bIns="18288">
-            <a:spAutoFit/>
-          </a:bodyPr>
-          <a:lstStyle/>
-          <a:p>
-            <a:pPr algn="ctr">
-              <a:spcAft>
-                <a:spcPts val="500"/>
-              </a:spcAft>
-              <a:defRPr sz="1600" b="1">
-                <a:solidFill>
-                  <a:srgbClr val="2D3748"/>
-                </a:solidFill>
-                <a:latin typeface="Liberation Sans"/>
-              </a:defRPr>
-            </a:pPr>
-            <a:r>
-              <a:t>Conductor y ayudantes</a:t>
-            </a:r>
-          </a:p>
-        </p:txBody>
-      </p:sp>
-      <p:sp>
-        <p:nvSpPr>
-          <p:cNvPr id="35" name="Rectangle 34"/>
-          <p:cNvSpPr/>
-          <p:nvPr/>
-        </p:nvSpPr>
-        <p:spPr>
-          <a:xfrm>
-            <a:off x="2999232" y="3602736"/>
-            <a:ext cx="2304288" cy="438912"/>
-          </a:xfrm>
-          <a:prstGeom prst="rect">
-            <a:avLst/>
-          </a:prstGeom>
-          <a:solidFill>
-            <a:srgbClr val="FFFFFF"/>
-          </a:solidFill>
-          <a:ln w="7620">
-            <a:solidFill>
-              <a:srgbClr val="D8E2E7"/>
-            </a:solidFill>
-          </a:ln>
-        </p:spPr>
-        <p:style>
-          <a:lnRef idx="1">
-            <a:schemeClr val="accent1"/>
-          </a:lnRef>
-          <a:fillRef idx="3">
-            <a:schemeClr val="accent1"/>
-          </a:fillRef>
-          <a:effectRef idx="2">
-            <a:schemeClr val="accent1"/>
-          </a:effectRef>
-          <a:fontRef idx="minor">
-            <a:schemeClr val="lt1"/>
-          </a:fontRef>
-        </p:style>
-        <p:txBody>
-          <a:bodyPr rtlCol="0" anchor="ctr"/>
-          <a:lstStyle/>
-          <a:p>
-            <a:pPr algn="ctr"/>
-          </a:p>
-        </p:txBody>
-      </p:sp>
-      <p:sp>
-        <p:nvSpPr>
-          <p:cNvPr id="36" name="TextBox 35"/>
-          <p:cNvSpPr txBox="1"/>
-          <p:nvPr/>
-        </p:nvSpPr>
-        <p:spPr>
-          <a:xfrm>
-            <a:off x="3063239" y="3694176"/>
-            <a:ext cx="2176272" cy="246888"/>
-          </a:xfrm>
-          <a:prstGeom prst="rect">
-            <a:avLst/>
-          </a:prstGeom>
-          <a:noFill/>
-        </p:spPr>
-        <p:txBody>
-          <a:bodyPr wrap="square" anchor="ctr" lIns="18288" rIns="18288" tIns="18288" bIns="18288">
-            <a:spAutoFit/>
-          </a:bodyPr>
-          <a:lstStyle/>
-          <a:p>
-            <a:pPr algn="ctr">
-              <a:spcAft>
-                <a:spcPts val="500"/>
-              </a:spcAft>
-              <a:defRPr sz="1500" b="0">
-                <a:solidFill>
-                  <a:srgbClr val="556373"/>
-                </a:solidFill>
-                <a:latin typeface="Liberation Sans"/>
-              </a:defRPr>
-            </a:pPr>
-            <a:r>
-              <a:t>sin dato</a:t>
-            </a:r>
-          </a:p>
-        </p:txBody>
-      </p:sp>
-      <p:sp>
-        <p:nvSpPr>
-          <p:cNvPr id="37" name="Rectangle 36"/>
-          <p:cNvSpPr/>
-          <p:nvPr/>
-        </p:nvSpPr>
-        <p:spPr>
-          <a:xfrm>
-            <a:off x="5303520" y="3602736"/>
-            <a:ext cx="2304288" cy="438912"/>
-          </a:xfrm>
-          <a:prstGeom prst="rect">
-            <a:avLst/>
-          </a:prstGeom>
-          <a:solidFill>
-            <a:srgbClr val="FFFFFF"/>
-          </a:solidFill>
-          <a:ln w="7620">
-            <a:solidFill>
-              <a:srgbClr val="D8E2E7"/>
-            </a:solidFill>
-          </a:ln>
-        </p:spPr>
-        <p:style>
-          <a:lnRef idx="1">
-            <a:schemeClr val="accent1"/>
-          </a:lnRef>
-          <a:fillRef idx="3">
-            <a:schemeClr val="accent1"/>
-          </a:fillRef>
-          <a:effectRef idx="2">
-            <a:schemeClr val="accent1"/>
-          </a:effectRef>
-          <a:fontRef idx="minor">
-            <a:schemeClr val="lt1"/>
-          </a:fontRef>
-        </p:style>
-        <p:txBody>
-          <a:bodyPr rtlCol="0" anchor="ctr"/>
-          <a:lstStyle/>
-          <a:p>
-            <a:pPr algn="ctr"/>
-          </a:p>
-        </p:txBody>
-      </p:sp>
-      <p:sp>
-        <p:nvSpPr>
-          <p:cNvPr id="38" name="TextBox 37"/>
-          <p:cNvSpPr txBox="1"/>
-          <p:nvPr/>
-        </p:nvSpPr>
-        <p:spPr>
-          <a:xfrm>
-            <a:off x="5367528" y="3694176"/>
-            <a:ext cx="2176272" cy="246888"/>
-          </a:xfrm>
-          <a:prstGeom prst="rect">
-            <a:avLst/>
-          </a:prstGeom>
-          <a:noFill/>
-        </p:spPr>
-        <p:txBody>
-          <a:bodyPr wrap="square" anchor="ctr" lIns="18288" rIns="18288" tIns="18288" bIns="18288">
-            <a:spAutoFit/>
-          </a:bodyPr>
-          <a:lstStyle/>
-          <a:p>
-            <a:pPr algn="ctr">
-              <a:spcAft>
-                <a:spcPts val="500"/>
-              </a:spcAft>
-              <a:defRPr sz="1500" b="0">
-                <a:solidFill>
-                  <a:srgbClr val="556373"/>
-                </a:solidFill>
-                <a:latin typeface="Liberation Sans"/>
-              </a:defRPr>
-            </a:pPr>
-            <a:r>
-              <a:t>sin dato</a:t>
-            </a:r>
-          </a:p>
-        </p:txBody>
-      </p:sp>
-      <p:sp>
-        <p:nvSpPr>
-          <p:cNvPr id="39" name="Rectangle 38"/>
-          <p:cNvSpPr/>
-          <p:nvPr/>
-        </p:nvSpPr>
-        <p:spPr>
-          <a:xfrm>
-            <a:off x="7607808" y="3602736"/>
-            <a:ext cx="2304288" cy="438912"/>
-          </a:xfrm>
-          <a:prstGeom prst="rect">
-            <a:avLst/>
-          </a:prstGeom>
-          <a:solidFill>
-            <a:srgbClr val="FFFFFF"/>
-          </a:solidFill>
-          <a:ln w="7620">
-            <a:solidFill>
-              <a:srgbClr val="D8E2E7"/>
-            </a:solidFill>
-          </a:ln>
-        </p:spPr>
-        <p:style>
-          <a:lnRef idx="1">
-            <a:schemeClr val="accent1"/>
-          </a:lnRef>
-          <a:fillRef idx="3">
-            <a:schemeClr val="accent1"/>
-          </a:fillRef>
-          <a:effectRef idx="2">
-            <a:schemeClr val="accent1"/>
-          </a:effectRef>
-          <a:fontRef idx="minor">
-            <a:schemeClr val="lt1"/>
-          </a:fontRef>
-        </p:style>
-        <p:txBody>
-          <a:bodyPr rtlCol="0" anchor="ctr"/>
-          <a:lstStyle/>
-          <a:p>
-            <a:pPr algn="ctr"/>
-          </a:p>
-        </p:txBody>
-      </p:sp>
-      <p:sp>
-        <p:nvSpPr>
-          <p:cNvPr id="40" name="TextBox 39"/>
-          <p:cNvSpPr txBox="1"/>
-          <p:nvPr/>
-        </p:nvSpPr>
-        <p:spPr>
-          <a:xfrm>
-            <a:off x="7671816" y="3694176"/>
-            <a:ext cx="2176272" cy="246888"/>
-          </a:xfrm>
-          <a:prstGeom prst="rect">
-            <a:avLst/>
-          </a:prstGeom>
-          <a:noFill/>
-        </p:spPr>
-        <p:txBody>
-          <a:bodyPr wrap="square" anchor="ctr" lIns="18288" rIns="18288" tIns="18288" bIns="18288">
-            <a:spAutoFit/>
-          </a:bodyPr>
-          <a:lstStyle/>
-          <a:p>
-            <a:pPr algn="ctr">
-              <a:spcAft>
-                <a:spcPts val="500"/>
-              </a:spcAft>
-              <a:defRPr sz="1500" b="0">
-                <a:solidFill>
-                  <a:srgbClr val="556373"/>
-                </a:solidFill>
-                <a:latin typeface="Liberation Sans"/>
-              </a:defRPr>
-            </a:pPr>
-            <a:r>
-              <a:t>sin dato</a:t>
-            </a:r>
-          </a:p>
-        </p:txBody>
-      </p:sp>
-      <p:sp>
-        <p:nvSpPr>
-          <p:cNvPr id="41" name="Rectangle 40"/>
-          <p:cNvSpPr/>
-          <p:nvPr/>
-        </p:nvSpPr>
-        <p:spPr>
-          <a:xfrm>
-            <a:off x="749808" y="4041648"/>
-            <a:ext cx="2249424" cy="438912"/>
-          </a:xfrm>
-          <a:prstGeom prst="rect">
-            <a:avLst/>
-          </a:prstGeom>
-          <a:solidFill>
-            <a:srgbClr val="E8F7FA"/>
-          </a:solidFill>
-          <a:ln w="7620">
-            <a:solidFill>
-              <a:srgbClr val="D8E2E7"/>
-            </a:solidFill>
-          </a:ln>
-        </p:spPr>
-        <p:style>
-          <a:lnRef idx="1">
-            <a:schemeClr val="accent1"/>
-          </a:lnRef>
-          <a:fillRef idx="3">
-            <a:schemeClr val="accent1"/>
-          </a:fillRef>
-          <a:effectRef idx="2">
-            <a:schemeClr val="accent1"/>
-          </a:effectRef>
-          <a:fontRef idx="minor">
-            <a:schemeClr val="lt1"/>
-          </a:fontRef>
-        </p:style>
-        <p:txBody>
-          <a:bodyPr rtlCol="0" anchor="ctr"/>
-          <a:lstStyle/>
-          <a:p>
-            <a:pPr algn="ctr"/>
-          </a:p>
-        </p:txBody>
-      </p:sp>
-      <p:sp>
-        <p:nvSpPr>
-          <p:cNvPr id="42" name="TextBox 41"/>
-          <p:cNvSpPr txBox="1"/>
-          <p:nvPr/>
-        </p:nvSpPr>
-        <p:spPr>
-          <a:xfrm>
-            <a:off x="813815" y="4133087"/>
-            <a:ext cx="2121408" cy="246888"/>
-          </a:xfrm>
-          <a:prstGeom prst="rect">
-            <a:avLst/>
-          </a:prstGeom>
-          <a:noFill/>
-        </p:spPr>
-        <p:txBody>
-          <a:bodyPr wrap="square" anchor="ctr" lIns="18288" rIns="18288" tIns="18288" bIns="18288">
-            <a:spAutoFit/>
-          </a:bodyPr>
-          <a:lstStyle/>
-          <a:p>
-            <a:pPr algn="ctr">
-              <a:spcAft>
-                <a:spcPts val="500"/>
-              </a:spcAft>
-              <a:defRPr sz="1600" b="1">
-                <a:solidFill>
-                  <a:srgbClr val="2D3748"/>
-                </a:solidFill>
-                <a:latin typeface="Liberation Sans"/>
-              </a:defRPr>
-            </a:pPr>
-            <a:r>
-              <a:t>Merma esperada</a:t>
-            </a:r>
-          </a:p>
-        </p:txBody>
-      </p:sp>
-      <p:sp>
-        <p:nvSpPr>
-          <p:cNvPr id="43" name="Rectangle 42"/>
-          <p:cNvSpPr/>
-          <p:nvPr/>
-        </p:nvSpPr>
-        <p:spPr>
-          <a:xfrm>
-            <a:off x="2999232" y="4041648"/>
-            <a:ext cx="2304288" cy="438912"/>
-          </a:xfrm>
-          <a:prstGeom prst="rect">
-            <a:avLst/>
-          </a:prstGeom>
-          <a:solidFill>
-            <a:srgbClr val="E8F7FA"/>
-          </a:solidFill>
-          <a:ln w="7620">
-            <a:solidFill>
-              <a:srgbClr val="D8E2E7"/>
-            </a:solidFill>
-          </a:ln>
-        </p:spPr>
-        <p:style>
-          <a:lnRef idx="1">
-            <a:schemeClr val="accent1"/>
-          </a:lnRef>
-          <a:fillRef idx="3">
-            <a:schemeClr val="accent1"/>
-          </a:fillRef>
-          <a:effectRef idx="2">
-            <a:schemeClr val="accent1"/>
-          </a:effectRef>
-          <a:fontRef idx="minor">
-            <a:schemeClr val="lt1"/>
-          </a:fontRef>
-        </p:style>
-        <p:txBody>
-          <a:bodyPr rtlCol="0" anchor="ctr"/>
-          <a:lstStyle/>
-          <a:p>
-            <a:pPr algn="ctr"/>
-          </a:p>
-        </p:txBody>
-      </p:sp>
-      <p:sp>
-        <p:nvSpPr>
-          <p:cNvPr id="44" name="TextBox 43"/>
-          <p:cNvSpPr txBox="1"/>
-          <p:nvPr/>
-        </p:nvSpPr>
-        <p:spPr>
-          <a:xfrm>
-            <a:off x="3063239" y="4133087"/>
-            <a:ext cx="2176272" cy="246888"/>
-          </a:xfrm>
-          <a:prstGeom prst="rect">
-            <a:avLst/>
-          </a:prstGeom>
-          <a:noFill/>
-        </p:spPr>
-        <p:txBody>
-          <a:bodyPr wrap="square" anchor="ctr" lIns="18288" rIns="18288" tIns="18288" bIns="18288">
-            <a:spAutoFit/>
-          </a:bodyPr>
-          <a:lstStyle/>
-          <a:p>
-            <a:pPr algn="ctr">
-              <a:spcAft>
-                <a:spcPts val="500"/>
-              </a:spcAft>
-              <a:defRPr sz="1500" b="0">
-                <a:solidFill>
-                  <a:srgbClr val="556373"/>
-                </a:solidFill>
-                <a:latin typeface="Liberation Sans"/>
-              </a:defRPr>
-            </a:pPr>
-            <a:r>
-              <a:t>sin dato</a:t>
-            </a:r>
-          </a:p>
-        </p:txBody>
-      </p:sp>
-      <p:sp>
-        <p:nvSpPr>
-          <p:cNvPr id="45" name="Rectangle 44"/>
-          <p:cNvSpPr/>
-          <p:nvPr/>
-        </p:nvSpPr>
-        <p:spPr>
-          <a:xfrm>
-            <a:off x="5303520" y="4041648"/>
-            <a:ext cx="2304288" cy="438912"/>
-          </a:xfrm>
-          <a:prstGeom prst="rect">
-            <a:avLst/>
-          </a:prstGeom>
-          <a:solidFill>
-            <a:srgbClr val="E8F7FA"/>
-          </a:solidFill>
-          <a:ln w="7620">
-            <a:solidFill>
-              <a:srgbClr val="D8E2E7"/>
-            </a:solidFill>
-          </a:ln>
-        </p:spPr>
-        <p:style>
-          <a:lnRef idx="1">
-            <a:schemeClr val="accent1"/>
-          </a:lnRef>
-          <a:fillRef idx="3">
-            <a:schemeClr val="accent1"/>
-          </a:fillRef>
-          <a:effectRef idx="2">
-            <a:schemeClr val="accent1"/>
-          </a:effectRef>
-          <a:fontRef idx="minor">
-            <a:schemeClr val="lt1"/>
-          </a:fontRef>
-        </p:style>
-        <p:txBody>
-          <a:bodyPr rtlCol="0" anchor="ctr"/>
-          <a:lstStyle/>
-          <a:p>
-            <a:pPr algn="ctr"/>
-          </a:p>
-        </p:txBody>
-      </p:sp>
-      <p:sp>
-        <p:nvSpPr>
-          <p:cNvPr id="46" name="TextBox 45"/>
-          <p:cNvSpPr txBox="1"/>
-          <p:nvPr/>
-        </p:nvSpPr>
-        <p:spPr>
-          <a:xfrm>
-            <a:off x="5367528" y="4133087"/>
-            <a:ext cx="2176272" cy="246888"/>
-          </a:xfrm>
-          <a:prstGeom prst="rect">
-            <a:avLst/>
-          </a:prstGeom>
-          <a:noFill/>
-        </p:spPr>
-        <p:txBody>
-          <a:bodyPr wrap="square" anchor="ctr" lIns="18288" rIns="18288" tIns="18288" bIns="18288">
-            <a:spAutoFit/>
-          </a:bodyPr>
-          <a:lstStyle/>
-          <a:p>
-            <a:pPr algn="ctr">
-              <a:spcAft>
-                <a:spcPts val="500"/>
-              </a:spcAft>
-              <a:defRPr sz="1500" b="0">
-                <a:solidFill>
-                  <a:srgbClr val="556373"/>
-                </a:solidFill>
-                <a:latin typeface="Liberation Sans"/>
-              </a:defRPr>
-            </a:pPr>
-            <a:r>
-              <a:t>sin dato</a:t>
-            </a:r>
-          </a:p>
-        </p:txBody>
-      </p:sp>
-      <p:sp>
-        <p:nvSpPr>
-          <p:cNvPr id="47" name="Rectangle 46"/>
-          <p:cNvSpPr/>
-          <p:nvPr/>
-        </p:nvSpPr>
-        <p:spPr>
-          <a:xfrm>
-            <a:off x="7607808" y="4041648"/>
-            <a:ext cx="2304288" cy="438912"/>
-          </a:xfrm>
-          <a:prstGeom prst="rect">
-            <a:avLst/>
-          </a:prstGeom>
-          <a:solidFill>
-            <a:srgbClr val="E8F7FA"/>
-          </a:solidFill>
-          <a:ln w="7620">
-            <a:solidFill>
-              <a:srgbClr val="D8E2E7"/>
-            </a:solidFill>
-          </a:ln>
-        </p:spPr>
-        <p:style>
-          <a:lnRef idx="1">
-            <a:schemeClr val="accent1"/>
-          </a:lnRef>
-          <a:fillRef idx="3">
-            <a:schemeClr val="accent1"/>
-          </a:fillRef>
-          <a:effectRef idx="2">
-            <a:schemeClr val="accent1"/>
-          </a:effectRef>
-          <a:fontRef idx="minor">
-            <a:schemeClr val="lt1"/>
-          </a:fontRef>
-        </p:style>
-        <p:txBody>
-          <a:bodyPr rtlCol="0" anchor="ctr"/>
-          <a:lstStyle/>
-          <a:p>
-            <a:pPr algn="ctr"/>
-          </a:p>
-        </p:txBody>
-      </p:sp>
-      <p:sp>
-        <p:nvSpPr>
-          <p:cNvPr id="48" name="TextBox 47"/>
-          <p:cNvSpPr txBox="1"/>
-          <p:nvPr/>
-        </p:nvSpPr>
-        <p:spPr>
-          <a:xfrm>
-            <a:off x="7671816" y="4133087"/>
-            <a:ext cx="2176272" cy="246888"/>
-          </a:xfrm>
-          <a:prstGeom prst="rect">
-            <a:avLst/>
-          </a:prstGeom>
-          <a:noFill/>
-        </p:spPr>
-        <p:txBody>
-          <a:bodyPr wrap="square" anchor="ctr" lIns="18288" rIns="18288" tIns="18288" bIns="18288">
-            <a:spAutoFit/>
-          </a:bodyPr>
-          <a:lstStyle/>
-          <a:p>
-            <a:pPr algn="ctr">
-              <a:spcAft>
-                <a:spcPts val="500"/>
-              </a:spcAft>
-              <a:defRPr sz="1500" b="0">
-                <a:solidFill>
-                  <a:srgbClr val="556373"/>
-                </a:solidFill>
-                <a:latin typeface="Liberation Sans"/>
-              </a:defRPr>
-            </a:pPr>
-            <a:r>
-              <a:t>sin dato</a:t>
-            </a:r>
-          </a:p>
-        </p:txBody>
-      </p:sp>
-      <p:sp>
-        <p:nvSpPr>
-          <p:cNvPr id="49" name="Rectangle 48"/>
-          <p:cNvSpPr/>
-          <p:nvPr/>
-        </p:nvSpPr>
-        <p:spPr>
-          <a:xfrm>
-            <a:off x="749808" y="4480560"/>
-            <a:ext cx="2249424" cy="438912"/>
-          </a:xfrm>
-          <a:prstGeom prst="rect">
-            <a:avLst/>
-          </a:prstGeom>
-          <a:solidFill>
-            <a:srgbClr val="FFFFFF"/>
-          </a:solidFill>
-          <a:ln w="7620">
-            <a:solidFill>
-              <a:srgbClr val="D8E2E7"/>
-            </a:solidFill>
-          </a:ln>
-        </p:spPr>
-        <p:style>
-          <a:lnRef idx="1">
-            <a:schemeClr val="accent1"/>
-          </a:lnRef>
-          <a:fillRef idx="3">
-            <a:schemeClr val="accent1"/>
-          </a:fillRef>
-          <a:effectRef idx="2">
-            <a:schemeClr val="accent1"/>
-          </a:effectRef>
-          <a:fontRef idx="minor">
-            <a:schemeClr val="lt1"/>
-          </a:fontRef>
-        </p:style>
-        <p:txBody>
-          <a:bodyPr rtlCol="0" anchor="ctr"/>
-          <a:lstStyle/>
-          <a:p>
-            <a:pPr algn="ctr"/>
-          </a:p>
-        </p:txBody>
-      </p:sp>
-      <p:sp>
-        <p:nvSpPr>
-          <p:cNvPr id="50" name="TextBox 49"/>
-          <p:cNvSpPr txBox="1"/>
-          <p:nvPr/>
-        </p:nvSpPr>
-        <p:spPr>
-          <a:xfrm>
-            <a:off x="813815" y="4572000"/>
-            <a:ext cx="2121408" cy="246888"/>
-          </a:xfrm>
-          <a:prstGeom prst="rect">
-            <a:avLst/>
-          </a:prstGeom>
-          <a:noFill/>
-        </p:spPr>
-        <p:txBody>
-          <a:bodyPr wrap="square" anchor="ctr" lIns="18288" rIns="18288" tIns="18288" bIns="18288">
-            <a:spAutoFit/>
-          </a:bodyPr>
-          <a:lstStyle/>
-          <a:p>
-            <a:pPr algn="ctr">
-              <a:spcAft>
-                <a:spcPts val="500"/>
-              </a:spcAft>
-              <a:defRPr sz="1600" b="1">
-                <a:solidFill>
-                  <a:srgbClr val="2D3748"/>
-                </a:solidFill>
-                <a:latin typeface="Liberation Sans"/>
-              </a:defRPr>
-            </a:pPr>
-            <a:r>
-              <a:t>Costo total</a:t>
-            </a:r>
-          </a:p>
-        </p:txBody>
-      </p:sp>
-      <p:sp>
-        <p:nvSpPr>
-          <p:cNvPr id="51" name="Rectangle 50"/>
-          <p:cNvSpPr/>
-          <p:nvPr/>
-        </p:nvSpPr>
-        <p:spPr>
-          <a:xfrm>
-            <a:off x="2999232" y="4480560"/>
-            <a:ext cx="2304288" cy="438912"/>
-          </a:xfrm>
-          <a:prstGeom prst="rect">
-            <a:avLst/>
-          </a:prstGeom>
-          <a:solidFill>
-            <a:srgbClr val="FFFFFF"/>
-          </a:solidFill>
-          <a:ln w="7620">
-            <a:solidFill>
-              <a:srgbClr val="D8E2E7"/>
-            </a:solidFill>
-          </a:ln>
-        </p:spPr>
-        <p:style>
-          <a:lnRef idx="1">
-            <a:schemeClr val="accent1"/>
-          </a:lnRef>
-          <a:fillRef idx="3">
-            <a:schemeClr val="accent1"/>
-          </a:fillRef>
-          <a:effectRef idx="2">
-            <a:schemeClr val="accent1"/>
-          </a:effectRef>
-          <a:fontRef idx="minor">
-            <a:schemeClr val="lt1"/>
-          </a:fontRef>
-        </p:style>
-        <p:txBody>
-          <a:bodyPr rtlCol="0" anchor="ctr"/>
-          <a:lstStyle/>
-          <a:p>
-            <a:pPr algn="ctr"/>
-          </a:p>
-        </p:txBody>
-      </p:sp>
-      <p:sp>
-        <p:nvSpPr>
-          <p:cNvPr id="52" name="TextBox 51"/>
-          <p:cNvSpPr txBox="1"/>
-          <p:nvPr/>
-        </p:nvSpPr>
-        <p:spPr>
-          <a:xfrm>
-            <a:off x="3063239" y="4572000"/>
-            <a:ext cx="2176272" cy="246888"/>
-          </a:xfrm>
-          <a:prstGeom prst="rect">
-            <a:avLst/>
-          </a:prstGeom>
-          <a:noFill/>
-        </p:spPr>
-        <p:txBody>
-          <a:bodyPr wrap="square" anchor="ctr" lIns="18288" rIns="18288" tIns="18288" bIns="18288">
-            <a:spAutoFit/>
-          </a:bodyPr>
-          <a:lstStyle/>
-          <a:p>
-            <a:pPr algn="ctr">
-              <a:spcAft>
-                <a:spcPts val="500"/>
-              </a:spcAft>
-              <a:defRPr sz="1500" b="0">
-                <a:solidFill>
-                  <a:srgbClr val="556373"/>
-                </a:solidFill>
-                <a:latin typeface="Liberation Sans"/>
-              </a:defRPr>
-            </a:pPr>
-            <a:r>
-              <a:t>sin dato</a:t>
-            </a:r>
-          </a:p>
-        </p:txBody>
-      </p:sp>
-      <p:sp>
-        <p:nvSpPr>
-          <p:cNvPr id="53" name="Rectangle 52"/>
-          <p:cNvSpPr/>
-          <p:nvPr/>
-        </p:nvSpPr>
-        <p:spPr>
-          <a:xfrm>
-            <a:off x="5303520" y="4480560"/>
-            <a:ext cx="2304288" cy="438912"/>
-          </a:xfrm>
-          <a:prstGeom prst="rect">
-            <a:avLst/>
-          </a:prstGeom>
-          <a:solidFill>
-            <a:srgbClr val="FFFFFF"/>
-          </a:solidFill>
-          <a:ln w="7620">
-            <a:solidFill>
-              <a:srgbClr val="D8E2E7"/>
-            </a:solidFill>
-          </a:ln>
-        </p:spPr>
-        <p:style>
-          <a:lnRef idx="1">
-            <a:schemeClr val="accent1"/>
-          </a:lnRef>
-          <a:fillRef idx="3">
-            <a:schemeClr val="accent1"/>
-          </a:fillRef>
-          <a:effectRef idx="2">
-            <a:schemeClr val="accent1"/>
-          </a:effectRef>
-          <a:fontRef idx="minor">
-            <a:schemeClr val="lt1"/>
-          </a:fontRef>
-        </p:style>
-        <p:txBody>
-          <a:bodyPr rtlCol="0" anchor="ctr"/>
-          <a:lstStyle/>
-          <a:p>
-            <a:pPr algn="ctr"/>
-          </a:p>
-        </p:txBody>
-      </p:sp>
-      <p:sp>
-        <p:nvSpPr>
-          <p:cNvPr id="54" name="TextBox 53"/>
-          <p:cNvSpPr txBox="1"/>
-          <p:nvPr/>
-        </p:nvSpPr>
-        <p:spPr>
-          <a:xfrm>
-            <a:off x="5367528" y="4572000"/>
-            <a:ext cx="2176272" cy="246888"/>
-          </a:xfrm>
-          <a:prstGeom prst="rect">
-            <a:avLst/>
-          </a:prstGeom>
-          <a:noFill/>
-        </p:spPr>
-        <p:txBody>
-          <a:bodyPr wrap="square" anchor="ctr" lIns="18288" rIns="18288" tIns="18288" bIns="18288">
-            <a:spAutoFit/>
-          </a:bodyPr>
-          <a:lstStyle/>
-          <a:p>
-            <a:pPr algn="ctr">
-              <a:spcAft>
-                <a:spcPts val="500"/>
-              </a:spcAft>
-              <a:defRPr sz="1500" b="0">
-                <a:solidFill>
-                  <a:srgbClr val="556373"/>
-                </a:solidFill>
-                <a:latin typeface="Liberation Sans"/>
-              </a:defRPr>
-            </a:pPr>
-            <a:r>
-              <a:t>sin dato</a:t>
-            </a:r>
-          </a:p>
-        </p:txBody>
-      </p:sp>
-      <p:sp>
-        <p:nvSpPr>
-          <p:cNvPr id="55" name="Rectangle 54"/>
-          <p:cNvSpPr/>
-          <p:nvPr/>
-        </p:nvSpPr>
-        <p:spPr>
-          <a:xfrm>
-            <a:off x="7607808" y="4480560"/>
-            <a:ext cx="2304288" cy="438912"/>
-          </a:xfrm>
-          <a:prstGeom prst="rect">
-            <a:avLst/>
-          </a:prstGeom>
-          <a:solidFill>
-            <a:srgbClr val="FFFFFF"/>
-          </a:solidFill>
-          <a:ln w="7620">
-            <a:solidFill>
-              <a:srgbClr val="D8E2E7"/>
-            </a:solidFill>
-          </a:ln>
-        </p:spPr>
-        <p:style>
-          <a:lnRef idx="1">
-            <a:schemeClr val="accent1"/>
-          </a:lnRef>
-          <a:fillRef idx="3">
-            <a:schemeClr val="accent1"/>
-          </a:fillRef>
-          <a:effectRef idx="2">
-            <a:schemeClr val="accent1"/>
-          </a:effectRef>
-          <a:fontRef idx="minor">
-            <a:schemeClr val="lt1"/>
-          </a:fontRef>
-        </p:style>
-        <p:txBody>
-          <a:bodyPr rtlCol="0" anchor="ctr"/>
-          <a:lstStyle/>
-          <a:p>
-            <a:pPr algn="ctr"/>
-          </a:p>
-        </p:txBody>
-      </p:sp>
-      <p:sp>
-        <p:nvSpPr>
-          <p:cNvPr id="56" name="TextBox 55"/>
-          <p:cNvSpPr txBox="1"/>
-          <p:nvPr/>
-        </p:nvSpPr>
-        <p:spPr>
-          <a:xfrm>
-            <a:off x="7671816" y="4572000"/>
-            <a:ext cx="2176272" cy="246888"/>
-          </a:xfrm>
-          <a:prstGeom prst="rect">
-            <a:avLst/>
-          </a:prstGeom>
-          <a:noFill/>
-        </p:spPr>
-        <p:txBody>
-          <a:bodyPr wrap="square" anchor="ctr" lIns="18288" rIns="18288" tIns="18288" bIns="18288">
-            <a:spAutoFit/>
-          </a:bodyPr>
-          <a:lstStyle/>
-          <a:p>
-            <a:pPr algn="ctr">
-              <a:spcAft>
-                <a:spcPts val="500"/>
-              </a:spcAft>
-              <a:defRPr sz="1500" b="0">
-                <a:solidFill>
-                  <a:srgbClr val="556373"/>
-                </a:solidFill>
-                <a:latin typeface="Liberation Sans"/>
-              </a:defRPr>
-            </a:pPr>
-            <a:r>
-              <a:t>sin dato</a:t>
-            </a:r>
-          </a:p>
-        </p:txBody>
-      </p:sp>
-      <p:sp>
-        <p:nvSpPr>
-          <p:cNvPr id="57" name="Rounded Rectangle 56"/>
-          <p:cNvSpPr/>
-          <p:nvPr/>
-        </p:nvSpPr>
-        <p:spPr>
-          <a:xfrm>
-            <a:off x="749808" y="5029200"/>
-            <a:ext cx="6839712" cy="603504"/>
-          </a:xfrm>
-          <a:prstGeom prst="roundRect">
-            <a:avLst/>
-          </a:prstGeom>
-          <a:solidFill>
-            <a:srgbClr val="F4F8E3"/>
-          </a:solidFill>
-          <a:ln w="12700">
-            <a:solidFill>
-              <a:srgbClr val="9EC200"/>
-            </a:solidFill>
-          </a:ln>
-        </p:spPr>
-        <p:style>
-          <a:lnRef idx="1">
-            <a:schemeClr val="accent1"/>
-          </a:lnRef>
-          <a:fillRef idx="3">
-            <a:schemeClr val="accent1"/>
-          </a:fillRef>
-          <a:effectRef idx="2">
-            <a:schemeClr val="accent1"/>
-          </a:effectRef>
-          <a:fontRef idx="minor">
-            <a:schemeClr val="lt1"/>
-          </a:fontRef>
-        </p:style>
-        <p:txBody>
-          <a:bodyPr rtlCol="0" anchor="ctr"/>
-          <a:lstStyle/>
-          <a:p>
-            <a:pPr algn="ctr"/>
-          </a:p>
-        </p:txBody>
-      </p:sp>
-      <p:sp>
-        <p:nvSpPr>
-          <p:cNvPr id="58" name="TextBox 57"/>
-          <p:cNvSpPr txBox="1"/>
-          <p:nvPr/>
-        </p:nvSpPr>
-        <p:spPr>
-          <a:xfrm>
-            <a:off x="914400" y="5111496"/>
-            <a:ext cx="6510528" cy="420624"/>
-          </a:xfrm>
-          <a:prstGeom prst="rect">
-            <a:avLst/>
-          </a:prstGeom>
-          <a:noFill/>
-        </p:spPr>
-        <p:txBody>
-          <a:bodyPr wrap="square" anchor="ctr" lIns="18288" rIns="18288" tIns="18288" bIns="18288">
-            <a:spAutoFit/>
-          </a:bodyPr>
-          <a:lstStyle/>
-          <a:p>
-            <a:pPr algn="l">
-              <a:spcAft>
-                <a:spcPts val="500"/>
-              </a:spcAft>
-              <a:defRPr sz="1700" b="1">
-                <a:solidFill>
-                  <a:srgbClr val="2D3748"/>
-                </a:solidFill>
-                <a:latin typeface="Liberation Sans"/>
-              </a:defRPr>
-            </a:pPr>
-            <a:r>
-              <a:t>Recomendada: sin dato · el planificador decide</a:t>
-            </a:r>
-          </a:p>
-        </p:txBody>
-      </p:sp>
-      <p:sp>
-        <p:nvSpPr>
-          <p:cNvPr id="59" name="Rounded Rectangle 58"/>
-          <p:cNvSpPr/>
-          <p:nvPr/>
-        </p:nvSpPr>
-        <p:spPr>
-          <a:xfrm>
-            <a:off x="7790688" y="5029200"/>
-            <a:ext cx="3767328" cy="603504"/>
-          </a:xfrm>
-          <a:prstGeom prst="roundRect">
-            <a:avLst/>
-          </a:prstGeom>
-          <a:solidFill>
-            <a:srgbClr val="F4F8FA"/>
-          </a:solidFill>
-          <a:ln w="12700">
-            <a:solidFill>
-              <a:srgbClr val="D8E2E7"/>
-            </a:solidFill>
-          </a:ln>
-        </p:spPr>
-        <p:style>
-          <a:lnRef idx="1">
-            <a:schemeClr val="accent1"/>
-          </a:lnRef>
-          <a:fillRef idx="3">
-            <a:schemeClr val="accent1"/>
-          </a:fillRef>
-          <a:effectRef idx="2">
-            <a:schemeClr val="accent1"/>
-          </a:effectRef>
-          <a:fontRef idx="minor">
-            <a:schemeClr val="lt1"/>
-          </a:fontRef>
-        </p:style>
-        <p:txBody>
-          <a:bodyPr rtlCol="0" anchor="ctr"/>
-          <a:lstStyle/>
-          <a:p>
-            <a:pPr algn="ctr"/>
-          </a:p>
-        </p:txBody>
-      </p:sp>
-      <p:sp>
-        <p:nvSpPr>
-          <p:cNvPr id="60" name="TextBox 59"/>
-          <p:cNvSpPr txBox="1"/>
-          <p:nvPr/>
-        </p:nvSpPr>
-        <p:spPr>
-          <a:xfrm>
-            <a:off x="7936992" y="5093208"/>
-            <a:ext cx="3474720" cy="457200"/>
-          </a:xfrm>
-          <a:prstGeom prst="rect">
-            <a:avLst/>
-          </a:prstGeom>
-          <a:noFill/>
-        </p:spPr>
-        <p:txBody>
-          <a:bodyPr wrap="square" anchor="ctr" lIns="18288" rIns="18288" tIns="18288" bIns="18288">
-            <a:spAutoFit/>
-          </a:bodyPr>
-          <a:lstStyle/>
-          <a:p>
-            <a:pPr algn="l">
-              <a:spcAft>
-                <a:spcPts val="500"/>
-              </a:spcAft>
-              <a:defRPr sz="1600" b="0">
-                <a:solidFill>
-                  <a:srgbClr val="2D3748"/>
-                </a:solidFill>
-                <a:latin typeface="Liberation Sans"/>
-              </a:defRPr>
-            </a:pPr>
-            <a:r>
-              <a:t>Justificación: pendiente de integrar el puntaje A/B/C.</a:t>
-            </a:r>
-          </a:p>
-        </p:txBody>
-      </p:sp>
-      <p:sp>
-        <p:nvSpPr>
-          <p:cNvPr id="61" name="Rounded Rectangle 60"/>
-          <p:cNvSpPr/>
-          <p:nvPr/>
-        </p:nvSpPr>
-        <p:spPr>
-          <a:xfrm>
-            <a:off x="749808" y="5715000"/>
-            <a:ext cx="10808208" cy="438912"/>
-          </a:xfrm>
-          <a:prstGeom prst="roundRect">
-            <a:avLst/>
-          </a:prstGeom>
-          <a:solidFill>
-            <a:srgbClr val="FDF0E9"/>
           </a:solidFill>
           <a:ln w="12700">
             <a:solidFill>
@@ -7979,8 +7979,8 @@
         </p:nvSpPr>
         <p:spPr>
           <a:xfrm>
-            <a:off x="914400" y="5760720"/>
-            <a:ext cx="10469880" cy="310896"/>
+            <a:off x="7955279" y="5614416"/>
+            <a:ext cx="3493008" cy="512064"/>
           </a:xfrm>
           <a:prstGeom prst="rect">
             <a:avLst/>
@@ -7997,7 +7997,7 @@
               <a:spcAft>
                 <a:spcPts val="500"/>
               </a:spcAft>
-              <a:defRPr sz="1700" b="1">
+              <a:defRPr sz="1500" b="1">
                 <a:solidFill>
                   <a:srgbClr val="2D3748"/>
                 </a:solidFill>

</xml_diff>